<commit_message>
Set training indicator to 2.87 percent per supplied reference
</commit_message>
<xml_diff>
--- a/informes/2026-10/entregables/SMP_HSE_Octubre_2026_Corte_27_BORRADOR_v02.pptx
+++ b/informes/2026-10/entregables/SMP_HSE_Octubre_2026_Corte_27_BORRADOR_v02.pptx
@@ -4113,13 +4113,19 @@
           </a:p>
           <a:p>
             <a:r>
-              <a:t>Pending for Oct-26: October bars and the training % card are marked in red until the data is loaded.</a:t>
+              <a:t>October bars remain pending. The training card displays 2.87%, as explicitly supplied by the user in the reference screenshot.</a:t>
             </a:r>
           </a:p>
           <a:p/>
           <a:p>
             <a:r>
               <a:t>La nueva lámina de seguridad con espacios para fotos y novedades de octubre va inmediatamente después de esta lámina de barras. Los gráficos y sus valores no se actualizan. Simulacros: meta 100% de los programados exigibles al corte; el conteo por sí solo no demuestra cumplimiento. Capacitación: (HHS/HHT) ×100, meta de la fuente ≥1%. No se requiere carga de datos en esta fase temática.</a:t>
+            </a:r>
+          </a:p>
+          <a:p/>
+          <a:p>
+            <a:r>
+              <a:t>ACTUALIZACIÓN DEL USUARIO: conservar 2.87% en Training % vs HHT, según el segundo pantallazo. Valor transcrito de la referencia recibida; no recalculado con HHS/HHT. Meta visible conservada: ≥1%. Los demás gráficos y pendientes se mantienen.</a:t>
             </a:r>
           </a:p>
         </p:txBody>
@@ -10956,11 +10962,11 @@
             <a:r>
               <a:rPr lang="en-GB" sz="2800" b="1" i="0" noProof="0" dirty="0">
                 <a:solidFill>
-                  <a:srgbClr val="FF0000"/>
+                  <a:srgbClr val="013EF5"/>
                 </a:solidFill>
                 <a:latin typeface="Aptos"/>
               </a:rPr>
-              <a:t>Pending</a:t>
+              <a:t>2.87%</a:t>
             </a:r>
           </a:p>
         </p:txBody>
@@ -11098,6 +11104,2233 @@
 </file>
 
 <file path=ppt/slides/slide5.xml><?xml version="1.0" encoding="utf-8"?>
+<p:sld xmlns:a="http://schemas.openxmlformats.org/drawingml/2006/main" xmlns:p="http://schemas.openxmlformats.org/presentationml/2006/main" xmlns:r="http://schemas.openxmlformats.org/officeDocument/2006/relationships">
+  <p:cSld>
+    <p:spTree>
+      <p:nvGrpSpPr>
+        <p:cNvPr id="1" name=""/>
+        <p:cNvGrpSpPr/>
+        <p:nvPr/>
+      </p:nvGrpSpPr>
+      <p:grpSpPr/>
+      <p:sp>
+        <p:nvSpPr>
+          <p:cNvPr id="8" name="Rectángulo 7">
+            <a:extLst>
+              <a:ext uri="{FF2B5EF4-FFF2-40B4-BE49-F238E27FC236}">
+                <a16:creationId xmlns:a16="http://schemas.microsoft.com/office/drawing/2014/main" id="{E0F0ACF1-FB3B-891E-E4C9-CEDACE965B70}"/>
+              </a:ext>
+            </a:extLst>
+          </p:cNvPr>
+          <p:cNvSpPr/>
+          <p:nvPr/>
+        </p:nvSpPr>
+        <p:spPr>
+          <a:xfrm>
+            <a:off x="0" y="0"/>
+            <a:ext cx="9144000" cy="706582"/>
+          </a:xfrm>
+          <a:prstGeom prst="rect">
+            <a:avLst/>
+          </a:prstGeom>
+          <a:solidFill>
+            <a:schemeClr val="bg1">
+              <a:lumMod val="95000"/>
+            </a:schemeClr>
+          </a:solidFill>
+          <a:ln>
+            <a:noFill/>
+          </a:ln>
+        </p:spPr>
+        <p:style>
+          <a:lnRef idx="2">
+            <a:schemeClr val="accent1">
+              <a:shade val="50000"/>
+            </a:schemeClr>
+          </a:lnRef>
+          <a:fillRef idx="1">
+            <a:schemeClr val="accent1"/>
+          </a:fillRef>
+          <a:effectRef idx="0">
+            <a:schemeClr val="accent1"/>
+          </a:effectRef>
+          <a:fontRef idx="minor">
+            <a:schemeClr val="lt1"/>
+          </a:fontRef>
+        </p:style>
+        <p:txBody>
+          <a:bodyPr rtlCol="0" anchor="ctr"/>
+          <a:lstStyle/>
+          <a:p>
+            <a:pPr algn="ctr"/>
+            <a:endParaRPr lang="en-GB" noProof="0" dirty="0"/>
+          </a:p>
+        </p:txBody>
+      </p:sp>
+      <p:sp>
+        <p:nvSpPr>
+          <p:cNvPr id="9" name="Título 1">
+            <a:extLst>
+              <a:ext uri="{FF2B5EF4-FFF2-40B4-BE49-F238E27FC236}">
+                <a16:creationId xmlns:a16="http://schemas.microsoft.com/office/drawing/2014/main" id="{2C399A2C-904E-A0D7-BF10-0536804170B1}"/>
+              </a:ext>
+            </a:extLst>
+          </p:cNvPr>
+          <p:cNvSpPr txBox="1">
+            <a:spLocks/>
+          </p:cNvSpPr>
+          <p:nvPr/>
+        </p:nvSpPr>
+        <p:spPr>
+          <a:xfrm>
+            <a:off x="179509" y="142504"/>
+            <a:ext cx="7863840" cy="475488"/>
+          </a:xfrm>
+          <a:prstGeom prst="rect">
+            <a:avLst/>
+          </a:prstGeom>
+        </p:spPr>
+        <p:txBody>
+          <a:bodyPr vert="horz" lIns="91440" tIns="45720" rIns="91440" bIns="45720" rtlCol="0" anchor="ctr">
+            <a:normAutofit/>
+          </a:bodyPr>
+          <a:lstStyle>
+            <a:lvl1pPr algn="ctr" defTabSz="914400" rtl="0" eaLnBrk="1" latinLnBrk="0" hangingPunct="1">
+              <a:spcBef>
+                <a:spcPct val="0"/>
+              </a:spcBef>
+              <a:buNone/>
+              <a:defRPr sz="4400" kern="1200">
+                <a:solidFill>
+                  <a:schemeClr val="tx1"/>
+                </a:solidFill>
+                <a:latin typeface="+mj-lt"/>
+                <a:ea typeface="+mj-ea"/>
+                <a:cs typeface="+mj-cs"/>
+              </a:defRPr>
+            </a:lvl1pPr>
+          </a:lstStyle>
+          <a:p>
+            <a:pPr algn="l"/>
+            <a:r>
+              <a:rPr sz="1400" b="1">
+                <a:solidFill>
+                  <a:srgbClr val="013EF5"/>
+                </a:solidFill>
+                <a:latin typeface="DejaVu Sans"/>
+              </a:rPr>
+              <a:t>1.1 &gt; DEDICATED GAS PIPELINE UPDATE &gt; Safety | October Highlights</a:t>
+            </a:r>
+          </a:p>
+        </p:txBody>
+      </p:sp>
+      <p:pic>
+        <p:nvPicPr>
+          <p:cNvPr id="11" name="Imagen 10">
+            <a:extLst>
+              <a:ext uri="{FF2B5EF4-FFF2-40B4-BE49-F238E27FC236}">
+                <a16:creationId xmlns:a16="http://schemas.microsoft.com/office/drawing/2014/main" id="{B890EEC0-89A1-F0FA-6F0E-CA480F8EF46C}"/>
+              </a:ext>
+            </a:extLst>
+          </p:cNvPr>
+          <p:cNvPicPr>
+            <a:picLocks noChangeAspect="1"/>
+          </p:cNvPicPr>
+          <p:nvPr/>
+        </p:nvPicPr>
+        <p:blipFill rotWithShape="1">
+          <a:blip r:embed="rId2"/>
+          <a:srcRect t="-1" r="54800" b="49955"/>
+          <a:stretch/>
+        </p:blipFill>
+        <p:spPr>
+          <a:xfrm>
+            <a:off x="8549908" y="117682"/>
+            <a:ext cx="274715" cy="232529"/>
+          </a:xfrm>
+          <a:prstGeom prst="rect">
+            <a:avLst/>
+          </a:prstGeom>
+        </p:spPr>
+      </p:pic>
+      <p:sp>
+        <p:nvSpPr>
+          <p:cNvPr id="12" name="CuadroTexto 11">
+            <a:extLst>
+              <a:ext uri="{FF2B5EF4-FFF2-40B4-BE49-F238E27FC236}">
+                <a16:creationId xmlns:a16="http://schemas.microsoft.com/office/drawing/2014/main" id="{8B51CD8C-DB5F-892A-4B92-E56F0244E354}"/>
+              </a:ext>
+            </a:extLst>
+          </p:cNvPr>
+          <p:cNvSpPr txBox="1"/>
+          <p:nvPr/>
+        </p:nvSpPr>
+        <p:spPr>
+          <a:xfrm>
+            <a:off x="8231453" y="321314"/>
+            <a:ext cx="1151431" cy="215444"/>
+          </a:xfrm>
+          <a:prstGeom prst="rect">
+            <a:avLst/>
+          </a:prstGeom>
+          <a:noFill/>
+        </p:spPr>
+        <p:txBody>
+          <a:bodyPr wrap="square" rtlCol="0">
+            <a:spAutoFit/>
+          </a:bodyPr>
+          <a:lstStyle/>
+          <a:p>
+            <a:r>
+              <a:rPr lang="en-GB" sz="800" spc="100" noProof="0" dirty="0">
+                <a:solidFill>
+                  <a:srgbClr val="FF0000"/>
+                </a:solidFill>
+                <a:latin typeface="Aptos Display" panose="020B0004020202020204" pitchFamily="34" charset="0"/>
+              </a:rPr>
+              <a:t>CONFIDENTIAL</a:t>
+            </a:r>
+          </a:p>
+        </p:txBody>
+      </p:sp>
+      <p:sp>
+        <p:nvSpPr>
+          <p:cNvPr id="13" name="TextBox 12"/>
+          <p:cNvSpPr txBox="1"/>
+          <p:nvPr/>
+        </p:nvSpPr>
+        <p:spPr>
+          <a:xfrm>
+            <a:off x="411480" y="850392"/>
+            <a:ext cx="8321040" cy="320040"/>
+          </a:xfrm>
+          <a:prstGeom prst="rect">
+            <a:avLst/>
+          </a:prstGeom>
+          <a:noFill/>
+        </p:spPr>
+        <p:txBody>
+          <a:bodyPr wrap="square" lIns="18288" rIns="18288" tIns="0" bIns="0">
+            <a:spAutoFit/>
+          </a:bodyPr>
+          <a:lstStyle/>
+          <a:p>
+            <a:pPr>
+              <a:spcAft>
+                <a:spcPts val="500"/>
+              </a:spcAft>
+              <a:defRPr sz="1100" b="1">
+                <a:solidFill>
+                  <a:srgbClr val="013EF5"/>
+                </a:solidFill>
+                <a:latin typeface="DejaVu Sans"/>
+              </a:defRPr>
+            </a:pPr>
+            <a:r>
+              <a:t>OCTOBER 2026 · PHOTOS &amp; RELEVANT HIGHLIGHTS · cut-off 27 Oct</a:t>
+            </a:r>
+          </a:p>
+        </p:txBody>
+      </p:sp>
+      <p:sp>
+        <p:nvSpPr>
+          <p:cNvPr id="14" name="Rectangle 13"/>
+          <p:cNvSpPr/>
+          <p:nvPr/>
+        </p:nvSpPr>
+        <p:spPr>
+          <a:xfrm>
+            <a:off x="411480" y="1417320"/>
+            <a:ext cx="4023360" cy="2331720"/>
+          </a:xfrm>
+          <a:prstGeom prst="rect">
+            <a:avLst/>
+          </a:prstGeom>
+          <a:solidFill>
+            <a:srgbClr val="F2F3F5"/>
+          </a:solidFill>
+          <a:ln>
+            <a:solidFill>
+              <a:srgbClr val="CDD2D9"/>
+            </a:solidFill>
+          </a:ln>
+          <a:effectLst/>
+        </p:spPr>
+        <p:style>
+          <a:lnRef idx="1">
+            <a:schemeClr val="accent1"/>
+          </a:lnRef>
+          <a:fillRef idx="3">
+            <a:schemeClr val="accent1"/>
+          </a:fillRef>
+          <a:effectRef idx="2">
+            <a:schemeClr val="accent1"/>
+          </a:effectRef>
+          <a:fontRef idx="minor">
+            <a:schemeClr val="lt1"/>
+          </a:fontRef>
+        </p:style>
+        <p:txBody>
+          <a:bodyPr rtlCol="0" anchor="ctr"/>
+          <a:lstStyle/>
+          <a:p>
+            <a:pPr algn="ctr"/>
+          </a:p>
+        </p:txBody>
+      </p:sp>
+      <p:sp>
+        <p:nvSpPr>
+          <p:cNvPr id="15" name="TextBox 14"/>
+          <p:cNvSpPr txBox="1"/>
+          <p:nvPr/>
+        </p:nvSpPr>
+        <p:spPr>
+          <a:xfrm>
+            <a:off x="548640" y="2148840"/>
+            <a:ext cx="3749039" cy="640080"/>
+          </a:xfrm>
+          <a:prstGeom prst="rect">
+            <a:avLst/>
+          </a:prstGeom>
+          <a:noFill/>
+        </p:spPr>
+        <p:txBody>
+          <a:bodyPr wrap="square" lIns="18288" rIns="18288" tIns="0" bIns="0">
+            <a:spAutoFit/>
+          </a:bodyPr>
+          <a:lstStyle/>
+          <a:p>
+            <a:pPr algn="ctr">
+              <a:spcAft>
+                <a:spcPts val="500"/>
+              </a:spcAft>
+              <a:defRPr sz="1500" b="0">
+                <a:solidFill>
+                  <a:srgbClr val="68717D"/>
+                </a:solidFill>
+                <a:latin typeface="DejaVu Sans"/>
+              </a:defRPr>
+            </a:pPr>
+            <a:r>
+              <a:t>OCTOBER PHOTO 1</a:t>
+            </a:r>
+          </a:p>
+          <a:p>
+            <a:pPr algn="ctr">
+              <a:spcAft>
+                <a:spcPts val="500"/>
+              </a:spcAft>
+              <a:defRPr sz="1500" b="0">
+                <a:solidFill>
+                  <a:srgbClr val="68717D"/>
+                </a:solidFill>
+                <a:latin typeface="DejaVu Sans"/>
+              </a:defRPr>
+            </a:pPr>
+            <a:r>
+              <a:t>Pending actual photo</a:t>
+            </a:r>
+          </a:p>
+        </p:txBody>
+      </p:sp>
+      <p:sp>
+        <p:nvSpPr>
+          <p:cNvPr id="16" name="TextBox 15"/>
+          <p:cNvSpPr txBox="1"/>
+          <p:nvPr/>
+        </p:nvSpPr>
+        <p:spPr>
+          <a:xfrm>
+            <a:off x="411480" y="3867912"/>
+            <a:ext cx="4023360" cy="502920"/>
+          </a:xfrm>
+          <a:prstGeom prst="rect">
+            <a:avLst/>
+          </a:prstGeom>
+          <a:noFill/>
+        </p:spPr>
+        <p:txBody>
+          <a:bodyPr wrap="square" lIns="18288" rIns="18288" tIns="0" bIns="0">
+            <a:spAutoFit/>
+          </a:bodyPr>
+          <a:lstStyle/>
+          <a:p>
+            <a:pPr>
+              <a:spcAft>
+                <a:spcPts val="500"/>
+              </a:spcAft>
+              <a:defRPr sz="950" b="0">
+                <a:solidFill>
+                  <a:srgbClr val="68717D"/>
+                </a:solidFill>
+                <a:latin typeface="DejaVu Sans"/>
+              </a:defRPr>
+            </a:pPr>
+            <a:r>
+              <a:t>Date / location / activity: pending confirmation</a:t>
+            </a:r>
+          </a:p>
+        </p:txBody>
+      </p:sp>
+      <p:sp>
+        <p:nvSpPr>
+          <p:cNvPr id="17" name="Rectangle 16"/>
+          <p:cNvSpPr/>
+          <p:nvPr/>
+        </p:nvSpPr>
+        <p:spPr>
+          <a:xfrm>
+            <a:off x="4681728" y="1417320"/>
+            <a:ext cx="4023360" cy="2331720"/>
+          </a:xfrm>
+          <a:prstGeom prst="rect">
+            <a:avLst/>
+          </a:prstGeom>
+          <a:solidFill>
+            <a:srgbClr val="F2F3F5"/>
+          </a:solidFill>
+          <a:ln>
+            <a:solidFill>
+              <a:srgbClr val="CDD2D9"/>
+            </a:solidFill>
+          </a:ln>
+          <a:effectLst/>
+        </p:spPr>
+        <p:style>
+          <a:lnRef idx="1">
+            <a:schemeClr val="accent1"/>
+          </a:lnRef>
+          <a:fillRef idx="3">
+            <a:schemeClr val="accent1"/>
+          </a:fillRef>
+          <a:effectRef idx="2">
+            <a:schemeClr val="accent1"/>
+          </a:effectRef>
+          <a:fontRef idx="minor">
+            <a:schemeClr val="lt1"/>
+          </a:fontRef>
+        </p:style>
+        <p:txBody>
+          <a:bodyPr rtlCol="0" anchor="ctr"/>
+          <a:lstStyle/>
+          <a:p>
+            <a:pPr algn="ctr"/>
+          </a:p>
+        </p:txBody>
+      </p:sp>
+      <p:sp>
+        <p:nvSpPr>
+          <p:cNvPr id="18" name="TextBox 17"/>
+          <p:cNvSpPr txBox="1"/>
+          <p:nvPr/>
+        </p:nvSpPr>
+        <p:spPr>
+          <a:xfrm>
+            <a:off x="4818888" y="2148840"/>
+            <a:ext cx="3749039" cy="640080"/>
+          </a:xfrm>
+          <a:prstGeom prst="rect">
+            <a:avLst/>
+          </a:prstGeom>
+          <a:noFill/>
+        </p:spPr>
+        <p:txBody>
+          <a:bodyPr wrap="square" lIns="18288" rIns="18288" tIns="0" bIns="0">
+            <a:spAutoFit/>
+          </a:bodyPr>
+          <a:lstStyle/>
+          <a:p>
+            <a:pPr algn="ctr">
+              <a:spcAft>
+                <a:spcPts val="500"/>
+              </a:spcAft>
+              <a:defRPr sz="1500" b="0">
+                <a:solidFill>
+                  <a:srgbClr val="68717D"/>
+                </a:solidFill>
+                <a:latin typeface="DejaVu Sans"/>
+              </a:defRPr>
+            </a:pPr>
+            <a:r>
+              <a:t>OCTOBER PHOTO 2</a:t>
+            </a:r>
+          </a:p>
+          <a:p>
+            <a:pPr algn="ctr">
+              <a:spcAft>
+                <a:spcPts val="500"/>
+              </a:spcAft>
+              <a:defRPr sz="1500" b="0">
+                <a:solidFill>
+                  <a:srgbClr val="68717D"/>
+                </a:solidFill>
+                <a:latin typeface="DejaVu Sans"/>
+              </a:defRPr>
+            </a:pPr>
+            <a:r>
+              <a:t>Pending actual photo</a:t>
+            </a:r>
+          </a:p>
+        </p:txBody>
+      </p:sp>
+      <p:sp>
+        <p:nvSpPr>
+          <p:cNvPr id="19" name="TextBox 18"/>
+          <p:cNvSpPr txBox="1"/>
+          <p:nvPr/>
+        </p:nvSpPr>
+        <p:spPr>
+          <a:xfrm>
+            <a:off x="4681728" y="3867912"/>
+            <a:ext cx="4023360" cy="502920"/>
+          </a:xfrm>
+          <a:prstGeom prst="rect">
+            <a:avLst/>
+          </a:prstGeom>
+          <a:noFill/>
+        </p:spPr>
+        <p:txBody>
+          <a:bodyPr wrap="square" lIns="18288" rIns="18288" tIns="0" bIns="0">
+            <a:spAutoFit/>
+          </a:bodyPr>
+          <a:lstStyle/>
+          <a:p>
+            <a:pPr>
+              <a:spcAft>
+                <a:spcPts val="500"/>
+              </a:spcAft>
+              <a:defRPr sz="950" b="0">
+                <a:solidFill>
+                  <a:srgbClr val="68717D"/>
+                </a:solidFill>
+                <a:latin typeface="DejaVu Sans"/>
+              </a:defRPr>
+            </a:pPr>
+            <a:r>
+              <a:t>Date / location / activity: pending confirmation</a:t>
+            </a:r>
+          </a:p>
+        </p:txBody>
+      </p:sp>
+      <p:sp>
+        <p:nvSpPr>
+          <p:cNvPr id="20" name="Rectangle 19"/>
+          <p:cNvSpPr/>
+          <p:nvPr/>
+        </p:nvSpPr>
+        <p:spPr>
+          <a:xfrm>
+            <a:off x="411480" y="4590288"/>
+            <a:ext cx="8293608" cy="1554480"/>
+          </a:xfrm>
+          <a:prstGeom prst="rect">
+            <a:avLst/>
+          </a:prstGeom>
+          <a:solidFill>
+            <a:srgbClr val="F2F3F5"/>
+          </a:solidFill>
+          <a:ln>
+            <a:noFill/>
+          </a:ln>
+          <a:effectLst/>
+        </p:spPr>
+        <p:style>
+          <a:lnRef idx="1">
+            <a:schemeClr val="accent1"/>
+          </a:lnRef>
+          <a:fillRef idx="3">
+            <a:schemeClr val="accent1"/>
+          </a:fillRef>
+          <a:effectRef idx="2">
+            <a:schemeClr val="accent1"/>
+          </a:effectRef>
+          <a:fontRef idx="minor">
+            <a:schemeClr val="lt1"/>
+          </a:fontRef>
+        </p:style>
+        <p:txBody>
+          <a:bodyPr rtlCol="0" anchor="ctr"/>
+          <a:lstStyle/>
+          <a:p>
+            <a:pPr algn="ctr"/>
+          </a:p>
+        </p:txBody>
+      </p:sp>
+      <p:sp>
+        <p:nvSpPr>
+          <p:cNvPr id="21" name="TextBox 20"/>
+          <p:cNvSpPr txBox="1"/>
+          <p:nvPr/>
+        </p:nvSpPr>
+        <p:spPr>
+          <a:xfrm>
+            <a:off x="566928" y="4727448"/>
+            <a:ext cx="8001000" cy="274320"/>
+          </a:xfrm>
+          <a:prstGeom prst="rect">
+            <a:avLst/>
+          </a:prstGeom>
+          <a:noFill/>
+        </p:spPr>
+        <p:txBody>
+          <a:bodyPr wrap="square" lIns="18288" rIns="18288" tIns="0" bIns="0">
+            <a:spAutoFit/>
+          </a:bodyPr>
+          <a:lstStyle/>
+          <a:p>
+            <a:pPr>
+              <a:spcAft>
+                <a:spcPts val="500"/>
+              </a:spcAft>
+              <a:defRPr sz="1200" b="1">
+                <a:solidFill>
+                  <a:srgbClr val="013EF5"/>
+                </a:solidFill>
+                <a:latin typeface="DejaVu Sans"/>
+              </a:defRPr>
+            </a:pPr>
+            <a:r>
+              <a:t>SAFETY — RELEVANT OCTOBER TOPICS</a:t>
+            </a:r>
+          </a:p>
+        </p:txBody>
+      </p:sp>
+      <p:sp>
+        <p:nvSpPr>
+          <p:cNvPr id="22" name="TextBox 21"/>
+          <p:cNvSpPr txBox="1"/>
+          <p:nvPr/>
+        </p:nvSpPr>
+        <p:spPr>
+          <a:xfrm>
+            <a:off x="566928" y="5184648"/>
+            <a:ext cx="7863840" cy="749808"/>
+          </a:xfrm>
+          <a:prstGeom prst="rect">
+            <a:avLst/>
+          </a:prstGeom>
+          <a:noFill/>
+        </p:spPr>
+        <p:txBody>
+          <a:bodyPr wrap="square" lIns="18288" rIns="18288" tIns="0" bIns="0">
+            <a:spAutoFit/>
+          </a:bodyPr>
+          <a:lstStyle/>
+          <a:p>
+            <a:pPr>
+              <a:spcAft>
+                <a:spcPts val="500"/>
+              </a:spcAft>
+              <a:defRPr sz="1200" b="0">
+                <a:solidFill>
+                  <a:srgbClr val="27364A"/>
+                </a:solidFill>
+                <a:latin typeface="DejaVu Sans"/>
+              </a:defRPr>
+            </a:pPr>
+            <a:r>
+              <a:t>[Pending topics from Leandro Doglio]</a:t>
+            </a:r>
+          </a:p>
+          <a:p>
+            <a:pPr>
+              <a:spcAft>
+                <a:spcPts val="500"/>
+              </a:spcAft>
+              <a:defRPr sz="1200" b="0">
+                <a:solidFill>
+                  <a:srgbClr val="27364A"/>
+                </a:solidFill>
+                <a:latin typeface="DejaVu Sans"/>
+              </a:defRPr>
+            </a:pPr>
+            <a:r>
+              <a:t>Confirmed development · relevance · next step</a:t>
+            </a:r>
+          </a:p>
+        </p:txBody>
+      </p:sp>
+      <p:sp>
+        <p:nvSpPr>
+          <p:cNvPr id="23" name="TextBox 22"/>
+          <p:cNvSpPr txBox="1"/>
+          <p:nvPr/>
+        </p:nvSpPr>
+        <p:spPr>
+          <a:xfrm>
+            <a:off x="3474720" y="6601968"/>
+            <a:ext cx="4389120" cy="155448"/>
+          </a:xfrm>
+          <a:prstGeom prst="rect">
+            <a:avLst/>
+          </a:prstGeom>
+          <a:noFill/>
+        </p:spPr>
+        <p:txBody>
+          <a:bodyPr wrap="square" lIns="18288" rIns="18288" tIns="0" bIns="0">
+            <a:spAutoFit/>
+          </a:bodyPr>
+          <a:lstStyle/>
+          <a:p>
+            <a:pPr>
+              <a:spcAft>
+                <a:spcPts val="500"/>
+              </a:spcAft>
+              <a:defRPr sz="650" b="0">
+                <a:solidFill>
+                  <a:srgbClr val="68717D"/>
+                </a:solidFill>
+                <a:latin typeface="DejaVu Sans"/>
+              </a:defRPr>
+            </a:pPr>
+            <a:r>
+              <a:t>WORKING DRAFT · October topics pending</a:t>
+            </a:r>
+          </a:p>
+        </p:txBody>
+      </p:sp>
+      <p:sp>
+        <p:nvSpPr>
+          <p:cNvPr id="24" name="TextBox 23"/>
+          <p:cNvSpPr txBox="1"/>
+          <p:nvPr/>
+        </p:nvSpPr>
+        <p:spPr>
+          <a:xfrm>
+            <a:off x="8595360" y="6556248"/>
+            <a:ext cx="274320" cy="201168"/>
+          </a:xfrm>
+          <a:prstGeom prst="rect">
+            <a:avLst/>
+          </a:prstGeom>
+          <a:noFill/>
+        </p:spPr>
+        <p:txBody>
+          <a:bodyPr wrap="square" lIns="18288" rIns="18288" tIns="0" bIns="0">
+            <a:spAutoFit/>
+          </a:bodyPr>
+          <a:lstStyle/>
+          <a:p>
+            <a:pPr algn="r">
+              <a:spcAft>
+                <a:spcPts val="500"/>
+              </a:spcAft>
+              <a:defRPr sz="800" b="0">
+                <a:solidFill>
+                  <a:srgbClr val="68717D"/>
+                </a:solidFill>
+                <a:latin typeface="DejaVu Sans"/>
+              </a:defRPr>
+            </a:pPr>
+            <a:r>
+              <a:t>5</a:t>
+            </a:r>
+          </a:p>
+        </p:txBody>
+      </p:sp>
+    </p:spTree>
+  </p:cSld>
+  <p:clrMapOvr>
+    <a:masterClrMapping/>
+  </p:clrMapOvr>
+</p:sld>
+</file>
+
+<file path=ppt/slides/slide6.xml><?xml version="1.0" encoding="utf-8"?>
+<p:sld xmlns:a="http://schemas.openxmlformats.org/drawingml/2006/main" xmlns:p="http://schemas.openxmlformats.org/presentationml/2006/main" xmlns:r="http://schemas.openxmlformats.org/officeDocument/2006/relationships">
+  <p:cSld>
+    <p:spTree>
+      <p:nvGrpSpPr>
+        <p:cNvPr id="1" name=""/>
+        <p:cNvGrpSpPr/>
+        <p:nvPr/>
+      </p:nvGrpSpPr>
+      <p:grpSpPr/>
+      <p:sp>
+        <p:nvSpPr>
+          <p:cNvPr id="8" name="Rectángulo 7">
+            <a:extLst>
+              <a:ext uri="{FF2B5EF4-FFF2-40B4-BE49-F238E27FC236}">
+                <a16:creationId xmlns:a16="http://schemas.microsoft.com/office/drawing/2014/main" id="{E0F0ACF1-FB3B-891E-E4C9-CEDACE965B70}"/>
+              </a:ext>
+            </a:extLst>
+          </p:cNvPr>
+          <p:cNvSpPr/>
+          <p:nvPr/>
+        </p:nvSpPr>
+        <p:spPr>
+          <a:xfrm>
+            <a:off x="0" y="0"/>
+            <a:ext cx="9144000" cy="706582"/>
+          </a:xfrm>
+          <a:prstGeom prst="rect">
+            <a:avLst/>
+          </a:prstGeom>
+          <a:solidFill>
+            <a:schemeClr val="bg1">
+              <a:lumMod val="95000"/>
+            </a:schemeClr>
+          </a:solidFill>
+          <a:ln>
+            <a:noFill/>
+          </a:ln>
+        </p:spPr>
+        <p:style>
+          <a:lnRef idx="2">
+            <a:schemeClr val="accent1">
+              <a:shade val="50000"/>
+            </a:schemeClr>
+          </a:lnRef>
+          <a:fillRef idx="1">
+            <a:schemeClr val="accent1"/>
+          </a:fillRef>
+          <a:effectRef idx="0">
+            <a:schemeClr val="accent1"/>
+          </a:effectRef>
+          <a:fontRef idx="minor">
+            <a:schemeClr val="lt1"/>
+          </a:fontRef>
+        </p:style>
+        <p:txBody>
+          <a:bodyPr rtlCol="0" anchor="ctr"/>
+          <a:lstStyle/>
+          <a:p>
+            <a:pPr algn="ctr"/>
+            <a:endParaRPr lang="en-GB" noProof="0" dirty="0"/>
+          </a:p>
+        </p:txBody>
+      </p:sp>
+      <p:sp>
+        <p:nvSpPr>
+          <p:cNvPr id="9" name="Título 1">
+            <a:extLst>
+              <a:ext uri="{FF2B5EF4-FFF2-40B4-BE49-F238E27FC236}">
+                <a16:creationId xmlns:a16="http://schemas.microsoft.com/office/drawing/2014/main" id="{2C399A2C-904E-A0D7-BF10-0536804170B1}"/>
+              </a:ext>
+            </a:extLst>
+          </p:cNvPr>
+          <p:cNvSpPr txBox="1">
+            <a:spLocks/>
+          </p:cNvSpPr>
+          <p:nvPr/>
+        </p:nvSpPr>
+        <p:spPr>
+          <a:xfrm>
+            <a:off x="179509" y="142504"/>
+            <a:ext cx="7863840" cy="475488"/>
+          </a:xfrm>
+          <a:prstGeom prst="rect">
+            <a:avLst/>
+          </a:prstGeom>
+        </p:spPr>
+        <p:txBody>
+          <a:bodyPr vert="horz" lIns="91440" tIns="45720" rIns="91440" bIns="45720" rtlCol="0" anchor="ctr">
+            <a:normAutofit/>
+          </a:bodyPr>
+          <a:lstStyle>
+            <a:lvl1pPr algn="ctr" defTabSz="914400" rtl="0" eaLnBrk="1" latinLnBrk="0" hangingPunct="1">
+              <a:spcBef>
+                <a:spcPct val="0"/>
+              </a:spcBef>
+              <a:buNone/>
+              <a:defRPr sz="4400" kern="1200">
+                <a:solidFill>
+                  <a:schemeClr val="tx1"/>
+                </a:solidFill>
+                <a:latin typeface="+mj-lt"/>
+                <a:ea typeface="+mj-ea"/>
+                <a:cs typeface="+mj-cs"/>
+              </a:defRPr>
+            </a:lvl1pPr>
+          </a:lstStyle>
+          <a:p>
+            <a:pPr algn="l"/>
+            <a:r>
+              <a:rPr sz="1400" b="1">
+                <a:solidFill>
+                  <a:srgbClr val="013EF5"/>
+                </a:solidFill>
+                <a:latin typeface="DejaVu Sans"/>
+              </a:rPr>
+              <a:t>1.3 &gt; DEDICATED GAS PIPELINE UPDATE &gt; Environmental Performance Indicators</a:t>
+            </a:r>
+          </a:p>
+        </p:txBody>
+      </p:sp>
+      <p:pic>
+        <p:nvPicPr>
+          <p:cNvPr id="11" name="Imagen 10">
+            <a:extLst>
+              <a:ext uri="{FF2B5EF4-FFF2-40B4-BE49-F238E27FC236}">
+                <a16:creationId xmlns:a16="http://schemas.microsoft.com/office/drawing/2014/main" id="{B890EEC0-89A1-F0FA-6F0E-CA480F8EF46C}"/>
+              </a:ext>
+            </a:extLst>
+          </p:cNvPr>
+          <p:cNvPicPr>
+            <a:picLocks noChangeAspect="1"/>
+          </p:cNvPicPr>
+          <p:nvPr/>
+        </p:nvPicPr>
+        <p:blipFill rotWithShape="1">
+          <a:blip r:embed="rId2"/>
+          <a:srcRect t="-1" r="54800" b="49955"/>
+          <a:stretch/>
+        </p:blipFill>
+        <p:spPr>
+          <a:xfrm>
+            <a:off x="8549908" y="117682"/>
+            <a:ext cx="274715" cy="232529"/>
+          </a:xfrm>
+          <a:prstGeom prst="rect">
+            <a:avLst/>
+          </a:prstGeom>
+        </p:spPr>
+      </p:pic>
+      <p:sp>
+        <p:nvSpPr>
+          <p:cNvPr id="12" name="CuadroTexto 11">
+            <a:extLst>
+              <a:ext uri="{FF2B5EF4-FFF2-40B4-BE49-F238E27FC236}">
+                <a16:creationId xmlns:a16="http://schemas.microsoft.com/office/drawing/2014/main" id="{8B51CD8C-DB5F-892A-4B92-E56F0244E354}"/>
+              </a:ext>
+            </a:extLst>
+          </p:cNvPr>
+          <p:cNvSpPr txBox="1"/>
+          <p:nvPr/>
+        </p:nvSpPr>
+        <p:spPr>
+          <a:xfrm>
+            <a:off x="8231453" y="321314"/>
+            <a:ext cx="1151431" cy="215444"/>
+          </a:xfrm>
+          <a:prstGeom prst="rect">
+            <a:avLst/>
+          </a:prstGeom>
+          <a:noFill/>
+        </p:spPr>
+        <p:txBody>
+          <a:bodyPr wrap="square" rtlCol="0">
+            <a:spAutoFit/>
+          </a:bodyPr>
+          <a:lstStyle/>
+          <a:p>
+            <a:r>
+              <a:rPr lang="en-GB" sz="800" spc="100" noProof="0" dirty="0">
+                <a:solidFill>
+                  <a:srgbClr val="FF0000"/>
+                </a:solidFill>
+                <a:latin typeface="Aptos Display" panose="020B0004020202020204" pitchFamily="34" charset="0"/>
+              </a:rPr>
+              <a:t>CONFIDENTIAL</a:t>
+            </a:r>
+          </a:p>
+        </p:txBody>
+      </p:sp>
+      <p:sp>
+        <p:nvSpPr>
+          <p:cNvPr id="13" name="TextBox 12"/>
+          <p:cNvSpPr txBox="1"/>
+          <p:nvPr/>
+        </p:nvSpPr>
+        <p:spPr>
+          <a:xfrm>
+            <a:off x="438912" y="832104"/>
+            <a:ext cx="8321040" cy="237744"/>
+          </a:xfrm>
+          <a:prstGeom prst="rect">
+            <a:avLst/>
+          </a:prstGeom>
+          <a:noFill/>
+        </p:spPr>
+        <p:txBody>
+          <a:bodyPr wrap="square" lIns="18288" rIns="18288" tIns="0" bIns="0">
+            <a:spAutoFit/>
+          </a:bodyPr>
+          <a:lstStyle/>
+          <a:p>
+            <a:pPr>
+              <a:spcAft>
+                <a:spcPts val="500"/>
+              </a:spcAft>
+              <a:defRPr sz="900" b="0">
+                <a:solidFill>
+                  <a:srgbClr val="68717D"/>
+                </a:solidFill>
+                <a:latin typeface="DejaVu Sans"/>
+              </a:defRPr>
+            </a:pPr>
+            <a:r>
+              <a:t>August–September historical data</a:t>
+            </a:r>
+          </a:p>
+        </p:txBody>
+      </p:sp>
+      <p:sp>
+        <p:nvSpPr>
+          <p:cNvPr id="14" name="TextBox 13"/>
+          <p:cNvSpPr txBox="1"/>
+          <p:nvPr/>
+        </p:nvSpPr>
+        <p:spPr>
+          <a:xfrm>
+            <a:off x="484632" y="1207008"/>
+            <a:ext cx="4023360" cy="274320"/>
+          </a:xfrm>
+          <a:prstGeom prst="rect">
+            <a:avLst/>
+          </a:prstGeom>
+          <a:noFill/>
+        </p:spPr>
+        <p:txBody>
+          <a:bodyPr wrap="square" lIns="18288" rIns="18288" tIns="0" bIns="0">
+            <a:spAutoFit/>
+          </a:bodyPr>
+          <a:lstStyle/>
+          <a:p>
+            <a:pPr>
+              <a:spcAft>
+                <a:spcPts val="500"/>
+              </a:spcAft>
+              <a:defRPr sz="1100" b="1">
+                <a:solidFill>
+                  <a:srgbClr val="013EF5"/>
+                </a:solidFill>
+                <a:latin typeface="DejaVu Sans"/>
+              </a:defRPr>
+            </a:pPr>
+            <a:r>
+              <a:t>TOTAL WASTE GENERATION (kg/month)</a:t>
+            </a:r>
+          </a:p>
+        </p:txBody>
+      </p:sp>
+      <p:graphicFrame>
+        <p:nvGraphicFramePr>
+          <p:cNvPr id="15" name="Chart 14"/>
+          <p:cNvGraphicFramePr>
+            <a:graphicFrameLocks noGrp="1"/>
+          </p:cNvGraphicFramePr>
+          <p:nvPr/>
+        </p:nvGraphicFramePr>
+        <p:xfrm>
+          <a:off x="457200" y="1572768"/>
+          <a:ext cx="3063240" cy="2121408"/>
+        </p:xfrm>
+        <a:graphic>
+          <a:graphicData uri="http://schemas.openxmlformats.org/drawingml/2006/chart">
+            <c:chart xmlns:c="http://schemas.openxmlformats.org/drawingml/2006/chart" r:id="rId3"/>
+          </a:graphicData>
+        </a:graphic>
+      </p:graphicFrame>
+      <p:sp>
+        <p:nvSpPr>
+          <p:cNvPr id="16" name="Rectangle 15"/>
+          <p:cNvSpPr/>
+          <p:nvPr/>
+        </p:nvSpPr>
+        <p:spPr>
+          <a:xfrm>
+            <a:off x="4114800" y="1901952"/>
+            <a:ext cx="2240280" cy="1024128"/>
+          </a:xfrm>
+          <a:prstGeom prst="rect">
+            <a:avLst/>
+          </a:prstGeom>
+          <a:solidFill>
+            <a:srgbClr val="F2F3F5"/>
+          </a:solidFill>
+          <a:ln>
+            <a:noFill/>
+          </a:ln>
+          <a:effectLst/>
+        </p:spPr>
+        <p:style>
+          <a:lnRef idx="1">
+            <a:schemeClr val="accent1"/>
+          </a:lnRef>
+          <a:fillRef idx="3">
+            <a:schemeClr val="accent1"/>
+          </a:fillRef>
+          <a:effectRef idx="2">
+            <a:schemeClr val="accent1"/>
+          </a:effectRef>
+          <a:fontRef idx="minor">
+            <a:schemeClr val="lt1"/>
+          </a:fontRef>
+        </p:style>
+        <p:txBody>
+          <a:bodyPr rtlCol="0" anchor="ctr"/>
+          <a:lstStyle/>
+          <a:p>
+            <a:pPr algn="ctr"/>
+          </a:p>
+        </p:txBody>
+      </p:sp>
+      <p:sp>
+        <p:nvSpPr>
+          <p:cNvPr id="17" name="Rectangle 16"/>
+          <p:cNvSpPr/>
+          <p:nvPr/>
+        </p:nvSpPr>
+        <p:spPr>
+          <a:xfrm>
+            <a:off x="4114800" y="1901952"/>
+            <a:ext cx="50292" cy="1024128"/>
+          </a:xfrm>
+          <a:prstGeom prst="rect">
+            <a:avLst/>
+          </a:prstGeom>
+          <a:solidFill>
+            <a:srgbClr val="013EF5"/>
+          </a:solidFill>
+          <a:ln>
+            <a:noFill/>
+          </a:ln>
+          <a:effectLst/>
+        </p:spPr>
+        <p:style>
+          <a:lnRef idx="1">
+            <a:schemeClr val="accent1"/>
+          </a:lnRef>
+          <a:fillRef idx="3">
+            <a:schemeClr val="accent1"/>
+          </a:fillRef>
+          <a:effectRef idx="2">
+            <a:schemeClr val="accent1"/>
+          </a:effectRef>
+          <a:fontRef idx="minor">
+            <a:schemeClr val="lt1"/>
+          </a:fontRef>
+        </p:style>
+        <p:txBody>
+          <a:bodyPr rtlCol="0" anchor="ctr"/>
+          <a:lstStyle/>
+          <a:p>
+            <a:pPr algn="ctr"/>
+          </a:p>
+        </p:txBody>
+      </p:sp>
+      <p:sp>
+        <p:nvSpPr>
+          <p:cNvPr id="18" name="TextBox 17"/>
+          <p:cNvSpPr txBox="1"/>
+          <p:nvPr/>
+        </p:nvSpPr>
+        <p:spPr>
+          <a:xfrm>
+            <a:off x="4224528" y="1984248"/>
+            <a:ext cx="2057400" cy="320040"/>
+          </a:xfrm>
+          <a:prstGeom prst="rect">
+            <a:avLst/>
+          </a:prstGeom>
+          <a:noFill/>
+        </p:spPr>
+        <p:txBody>
+          <a:bodyPr wrap="square" lIns="18288" rIns="18288" tIns="0" bIns="0">
+            <a:spAutoFit/>
+          </a:bodyPr>
+          <a:lstStyle/>
+          <a:p>
+            <a:pPr>
+              <a:spcAft>
+                <a:spcPts val="500"/>
+              </a:spcAft>
+              <a:defRPr sz="850" b="1">
+                <a:solidFill>
+                  <a:srgbClr val="68717D"/>
+                </a:solidFill>
+                <a:latin typeface="DejaVu Sans"/>
+              </a:defRPr>
+            </a:pPr>
+            <a:r>
+              <a:t>% Waste recovery</a:t>
+            </a:r>
+          </a:p>
+        </p:txBody>
+      </p:sp>
+      <p:sp>
+        <p:nvSpPr>
+          <p:cNvPr id="19" name="TextBox 18"/>
+          <p:cNvSpPr txBox="1"/>
+          <p:nvPr/>
+        </p:nvSpPr>
+        <p:spPr>
+          <a:xfrm>
+            <a:off x="4224528" y="2359152"/>
+            <a:ext cx="2011680" cy="475488"/>
+          </a:xfrm>
+          <a:prstGeom prst="rect">
+            <a:avLst/>
+          </a:prstGeom>
+          <a:noFill/>
+        </p:spPr>
+        <p:txBody>
+          <a:bodyPr wrap="square" lIns="18288" rIns="18288" tIns="0" bIns="0">
+            <a:spAutoFit/>
+          </a:bodyPr>
+          <a:lstStyle/>
+          <a:p>
+            <a:pPr>
+              <a:spcAft>
+                <a:spcPts val="500"/>
+              </a:spcAft>
+              <a:defRPr sz="2800" b="1">
+                <a:solidFill>
+                  <a:srgbClr val="013EF5"/>
+                </a:solidFill>
+                <a:latin typeface="DejaVu Sans"/>
+              </a:defRPr>
+            </a:pPr>
+            <a:r>
+              <a:t>0%</a:t>
+            </a:r>
+          </a:p>
+        </p:txBody>
+      </p:sp>
+      <p:sp>
+        <p:nvSpPr>
+          <p:cNvPr id="20" name="Rectangle 19"/>
+          <p:cNvSpPr/>
+          <p:nvPr/>
+        </p:nvSpPr>
+        <p:spPr>
+          <a:xfrm>
+            <a:off x="6446520" y="1901952"/>
+            <a:ext cx="2240280" cy="1024128"/>
+          </a:xfrm>
+          <a:prstGeom prst="rect">
+            <a:avLst/>
+          </a:prstGeom>
+          <a:solidFill>
+            <a:srgbClr val="F2F3F5"/>
+          </a:solidFill>
+          <a:ln>
+            <a:noFill/>
+          </a:ln>
+          <a:effectLst/>
+        </p:spPr>
+        <p:style>
+          <a:lnRef idx="1">
+            <a:schemeClr val="accent1"/>
+          </a:lnRef>
+          <a:fillRef idx="3">
+            <a:schemeClr val="accent1"/>
+          </a:fillRef>
+          <a:effectRef idx="2">
+            <a:schemeClr val="accent1"/>
+          </a:effectRef>
+          <a:fontRef idx="minor">
+            <a:schemeClr val="lt1"/>
+          </a:fontRef>
+        </p:style>
+        <p:txBody>
+          <a:bodyPr rtlCol="0" anchor="ctr"/>
+          <a:lstStyle/>
+          <a:p>
+            <a:pPr algn="ctr"/>
+          </a:p>
+        </p:txBody>
+      </p:sp>
+      <p:sp>
+        <p:nvSpPr>
+          <p:cNvPr id="21" name="Rectangle 20"/>
+          <p:cNvSpPr/>
+          <p:nvPr/>
+        </p:nvSpPr>
+        <p:spPr>
+          <a:xfrm>
+            <a:off x="6446520" y="1901952"/>
+            <a:ext cx="50292" cy="1024128"/>
+          </a:xfrm>
+          <a:prstGeom prst="rect">
+            <a:avLst/>
+          </a:prstGeom>
+          <a:solidFill>
+            <a:srgbClr val="013EF5"/>
+          </a:solidFill>
+          <a:ln>
+            <a:noFill/>
+          </a:ln>
+          <a:effectLst/>
+        </p:spPr>
+        <p:style>
+          <a:lnRef idx="1">
+            <a:schemeClr val="accent1"/>
+          </a:lnRef>
+          <a:fillRef idx="3">
+            <a:schemeClr val="accent1"/>
+          </a:fillRef>
+          <a:effectRef idx="2">
+            <a:schemeClr val="accent1"/>
+          </a:effectRef>
+          <a:fontRef idx="minor">
+            <a:schemeClr val="lt1"/>
+          </a:fontRef>
+        </p:style>
+        <p:txBody>
+          <a:bodyPr rtlCol="0" anchor="ctr"/>
+          <a:lstStyle/>
+          <a:p>
+            <a:pPr algn="ctr"/>
+          </a:p>
+        </p:txBody>
+      </p:sp>
+      <p:sp>
+        <p:nvSpPr>
+          <p:cNvPr id="22" name="TextBox 21"/>
+          <p:cNvSpPr txBox="1"/>
+          <p:nvPr/>
+        </p:nvSpPr>
+        <p:spPr>
+          <a:xfrm>
+            <a:off x="6556248" y="1984248"/>
+            <a:ext cx="2057400" cy="320040"/>
+          </a:xfrm>
+          <a:prstGeom prst="rect">
+            <a:avLst/>
+          </a:prstGeom>
+          <a:noFill/>
+        </p:spPr>
+        <p:txBody>
+          <a:bodyPr wrap="square" lIns="18288" rIns="18288" tIns="0" bIns="0">
+            <a:spAutoFit/>
+          </a:bodyPr>
+          <a:lstStyle/>
+          <a:p>
+            <a:pPr>
+              <a:spcAft>
+                <a:spcPts val="500"/>
+              </a:spcAft>
+              <a:defRPr sz="850" b="1">
+                <a:solidFill>
+                  <a:srgbClr val="68717D"/>
+                </a:solidFill>
+                <a:latin typeface="DejaVu Sans"/>
+              </a:defRPr>
+            </a:pPr>
+            <a:r>
+              <a:t>% Waste final disposal / incinerated</a:t>
+            </a:r>
+          </a:p>
+        </p:txBody>
+      </p:sp>
+      <p:sp>
+        <p:nvSpPr>
+          <p:cNvPr id="23" name="TextBox 22"/>
+          <p:cNvSpPr txBox="1"/>
+          <p:nvPr/>
+        </p:nvSpPr>
+        <p:spPr>
+          <a:xfrm>
+            <a:off x="6556248" y="2359152"/>
+            <a:ext cx="2011680" cy="475488"/>
+          </a:xfrm>
+          <a:prstGeom prst="rect">
+            <a:avLst/>
+          </a:prstGeom>
+          <a:noFill/>
+        </p:spPr>
+        <p:txBody>
+          <a:bodyPr wrap="square" lIns="18288" rIns="18288" tIns="0" bIns="0">
+            <a:spAutoFit/>
+          </a:bodyPr>
+          <a:lstStyle/>
+          <a:p>
+            <a:pPr>
+              <a:spcAft>
+                <a:spcPts val="500"/>
+              </a:spcAft>
+              <a:defRPr sz="2800" b="1">
+                <a:solidFill>
+                  <a:srgbClr val="013EF5"/>
+                </a:solidFill>
+                <a:latin typeface="DejaVu Sans"/>
+              </a:defRPr>
+            </a:pPr>
+            <a:r>
+              <a:t>100%</a:t>
+            </a:r>
+          </a:p>
+        </p:txBody>
+      </p:sp>
+      <p:sp>
+        <p:nvSpPr>
+          <p:cNvPr id="24" name="TextBox 23"/>
+          <p:cNvSpPr txBox="1"/>
+          <p:nvPr/>
+        </p:nvSpPr>
+        <p:spPr>
+          <a:xfrm>
+            <a:off x="484632" y="4023360"/>
+            <a:ext cx="4846320" cy="274320"/>
+          </a:xfrm>
+          <a:prstGeom prst="rect">
+            <a:avLst/>
+          </a:prstGeom>
+          <a:noFill/>
+        </p:spPr>
+        <p:txBody>
+          <a:bodyPr wrap="square" lIns="18288" rIns="18288" tIns="0" bIns="0">
+            <a:spAutoFit/>
+          </a:bodyPr>
+          <a:lstStyle/>
+          <a:p>
+            <a:pPr>
+              <a:spcAft>
+                <a:spcPts val="500"/>
+              </a:spcAft>
+              <a:defRPr sz="1100" b="1">
+                <a:solidFill>
+                  <a:srgbClr val="013EF5"/>
+                </a:solidFill>
+                <a:latin typeface="DejaVu Sans"/>
+              </a:defRPr>
+            </a:pPr>
+            <a:r>
+              <a:t>FRESHWATER CONSUMPTION (m³/month)</a:t>
+            </a:r>
+          </a:p>
+        </p:txBody>
+      </p:sp>
+      <p:graphicFrame>
+        <p:nvGraphicFramePr>
+          <p:cNvPr id="25" name="Chart 24"/>
+          <p:cNvGraphicFramePr>
+            <a:graphicFrameLocks noGrp="1"/>
+          </p:cNvGraphicFramePr>
+          <p:nvPr/>
+        </p:nvGraphicFramePr>
+        <p:xfrm>
+          <a:off x="457200" y="4370832"/>
+          <a:ext cx="3063240" cy="1947672"/>
+        </p:xfrm>
+        <a:graphic>
+          <a:graphicData uri="http://schemas.openxmlformats.org/drawingml/2006/chart">
+            <c:chart xmlns:c="http://schemas.openxmlformats.org/drawingml/2006/chart" r:id="rId4"/>
+          </a:graphicData>
+        </a:graphic>
+      </p:graphicFrame>
+      <p:sp>
+        <p:nvSpPr>
+          <p:cNvPr id="26" name="TextBox 25"/>
+          <p:cNvSpPr txBox="1"/>
+          <p:nvPr/>
+        </p:nvSpPr>
+        <p:spPr>
+          <a:xfrm>
+            <a:off x="3474720" y="6601968"/>
+            <a:ext cx="4389120" cy="155448"/>
+          </a:xfrm>
+          <a:prstGeom prst="rect">
+            <a:avLst/>
+          </a:prstGeom>
+          <a:noFill/>
+        </p:spPr>
+        <p:txBody>
+          <a:bodyPr wrap="square" lIns="18288" rIns="18288" tIns="0" bIns="0">
+            <a:spAutoFit/>
+          </a:bodyPr>
+          <a:lstStyle/>
+          <a:p>
+            <a:pPr>
+              <a:spcAft>
+                <a:spcPts val="500"/>
+              </a:spcAft>
+              <a:defRPr sz="650" b="0">
+                <a:solidFill>
+                  <a:srgbClr val="68717D"/>
+                </a:solidFill>
+                <a:latin typeface="DejaVu Sans"/>
+              </a:defRPr>
+            </a:pPr>
+            <a:r>
+              <a:t>WORKING DRAFT · October topics pending</a:t>
+            </a:r>
+          </a:p>
+        </p:txBody>
+      </p:sp>
+      <p:sp>
+        <p:nvSpPr>
+          <p:cNvPr id="27" name="TextBox 26"/>
+          <p:cNvSpPr txBox="1"/>
+          <p:nvPr/>
+        </p:nvSpPr>
+        <p:spPr>
+          <a:xfrm>
+            <a:off x="8595360" y="6556248"/>
+            <a:ext cx="274320" cy="201168"/>
+          </a:xfrm>
+          <a:prstGeom prst="rect">
+            <a:avLst/>
+          </a:prstGeom>
+          <a:noFill/>
+        </p:spPr>
+        <p:txBody>
+          <a:bodyPr wrap="square" lIns="18288" rIns="18288" tIns="0" bIns="0">
+            <a:spAutoFit/>
+          </a:bodyPr>
+          <a:lstStyle/>
+          <a:p>
+            <a:pPr algn="r">
+              <a:spcAft>
+                <a:spcPts val="500"/>
+              </a:spcAft>
+              <a:defRPr sz="800" b="0">
+                <a:solidFill>
+                  <a:srgbClr val="68717D"/>
+                </a:solidFill>
+                <a:latin typeface="DejaVu Sans"/>
+              </a:defRPr>
+            </a:pPr>
+            <a:r>
+              <a:t>6</a:t>
+            </a:r>
+          </a:p>
+        </p:txBody>
+      </p:sp>
+    </p:spTree>
+  </p:cSld>
+  <p:clrMapOvr>
+    <a:masterClrMapping/>
+  </p:clrMapOvr>
+</p:sld>
+</file>
+
+<file path=ppt/slides/slide7.xml><?xml version="1.0" encoding="utf-8"?>
+<p:sld xmlns:a="http://schemas.openxmlformats.org/drawingml/2006/main" xmlns:p="http://schemas.openxmlformats.org/presentationml/2006/main" xmlns:r="http://schemas.openxmlformats.org/officeDocument/2006/relationships">
+  <p:cSld>
+    <p:spTree>
+      <p:nvGrpSpPr>
+        <p:cNvPr id="1" name=""/>
+        <p:cNvGrpSpPr/>
+        <p:nvPr/>
+      </p:nvGrpSpPr>
+      <p:grpSpPr/>
+      <p:sp>
+        <p:nvSpPr>
+          <p:cNvPr id="8" name="Rectángulo 7">
+            <a:extLst>
+              <a:ext uri="{FF2B5EF4-FFF2-40B4-BE49-F238E27FC236}">
+                <a16:creationId xmlns:a16="http://schemas.microsoft.com/office/drawing/2014/main" id="{E0F0ACF1-FB3B-891E-E4C9-CEDACE965B70}"/>
+              </a:ext>
+            </a:extLst>
+          </p:cNvPr>
+          <p:cNvSpPr/>
+          <p:nvPr/>
+        </p:nvSpPr>
+        <p:spPr>
+          <a:xfrm>
+            <a:off x="0" y="0"/>
+            <a:ext cx="9144000" cy="706582"/>
+          </a:xfrm>
+          <a:prstGeom prst="rect">
+            <a:avLst/>
+          </a:prstGeom>
+          <a:solidFill>
+            <a:schemeClr val="bg1">
+              <a:lumMod val="95000"/>
+            </a:schemeClr>
+          </a:solidFill>
+          <a:ln>
+            <a:noFill/>
+          </a:ln>
+        </p:spPr>
+        <p:style>
+          <a:lnRef idx="2">
+            <a:schemeClr val="accent1">
+              <a:shade val="50000"/>
+            </a:schemeClr>
+          </a:lnRef>
+          <a:fillRef idx="1">
+            <a:schemeClr val="accent1"/>
+          </a:fillRef>
+          <a:effectRef idx="0">
+            <a:schemeClr val="accent1"/>
+          </a:effectRef>
+          <a:fontRef idx="minor">
+            <a:schemeClr val="lt1"/>
+          </a:fontRef>
+        </p:style>
+        <p:txBody>
+          <a:bodyPr rtlCol="0" anchor="ctr"/>
+          <a:lstStyle/>
+          <a:p>
+            <a:pPr algn="ctr"/>
+            <a:endParaRPr lang="en-GB" noProof="0" dirty="0"/>
+          </a:p>
+        </p:txBody>
+      </p:sp>
+      <p:sp>
+        <p:nvSpPr>
+          <p:cNvPr id="9" name="Título 1">
+            <a:extLst>
+              <a:ext uri="{FF2B5EF4-FFF2-40B4-BE49-F238E27FC236}">
+                <a16:creationId xmlns:a16="http://schemas.microsoft.com/office/drawing/2014/main" id="{2C399A2C-904E-A0D7-BF10-0536804170B1}"/>
+              </a:ext>
+            </a:extLst>
+          </p:cNvPr>
+          <p:cNvSpPr txBox="1">
+            <a:spLocks/>
+          </p:cNvSpPr>
+          <p:nvPr/>
+        </p:nvSpPr>
+        <p:spPr>
+          <a:xfrm>
+            <a:off x="179509" y="142504"/>
+            <a:ext cx="7863840" cy="475488"/>
+          </a:xfrm>
+          <a:prstGeom prst="rect">
+            <a:avLst/>
+          </a:prstGeom>
+        </p:spPr>
+        <p:txBody>
+          <a:bodyPr vert="horz" lIns="91440" tIns="45720" rIns="91440" bIns="45720" rtlCol="0" anchor="ctr">
+            <a:normAutofit/>
+          </a:bodyPr>
+          <a:lstStyle>
+            <a:lvl1pPr algn="ctr" defTabSz="914400" rtl="0" eaLnBrk="1" latinLnBrk="0" hangingPunct="1">
+              <a:spcBef>
+                <a:spcPct val="0"/>
+              </a:spcBef>
+              <a:buNone/>
+              <a:defRPr sz="4400" kern="1200">
+                <a:solidFill>
+                  <a:schemeClr val="tx1"/>
+                </a:solidFill>
+                <a:latin typeface="+mj-lt"/>
+                <a:ea typeface="+mj-ea"/>
+                <a:cs typeface="+mj-cs"/>
+              </a:defRPr>
+            </a:lvl1pPr>
+          </a:lstStyle>
+          <a:p>
+            <a:pPr algn="l"/>
+            <a:r>
+              <a:rPr sz="1400" b="1">
+                <a:solidFill>
+                  <a:srgbClr val="013EF5"/>
+                </a:solidFill>
+                <a:latin typeface="DejaVu Sans"/>
+              </a:rPr>
+              <a:t>1.3 &gt; DEDICATED GAS PIPELINE UPDATE &gt; Environment | October Highlights</a:t>
+            </a:r>
+          </a:p>
+        </p:txBody>
+      </p:sp>
+      <p:pic>
+        <p:nvPicPr>
+          <p:cNvPr id="11" name="Imagen 10">
+            <a:extLst>
+              <a:ext uri="{FF2B5EF4-FFF2-40B4-BE49-F238E27FC236}">
+                <a16:creationId xmlns:a16="http://schemas.microsoft.com/office/drawing/2014/main" id="{B890EEC0-89A1-F0FA-6F0E-CA480F8EF46C}"/>
+              </a:ext>
+            </a:extLst>
+          </p:cNvPr>
+          <p:cNvPicPr>
+            <a:picLocks noChangeAspect="1"/>
+          </p:cNvPicPr>
+          <p:nvPr/>
+        </p:nvPicPr>
+        <p:blipFill rotWithShape="1">
+          <a:blip r:embed="rId2"/>
+          <a:srcRect t="-1" r="54800" b="49955"/>
+          <a:stretch/>
+        </p:blipFill>
+        <p:spPr>
+          <a:xfrm>
+            <a:off x="8549908" y="117682"/>
+            <a:ext cx="274715" cy="232529"/>
+          </a:xfrm>
+          <a:prstGeom prst="rect">
+            <a:avLst/>
+          </a:prstGeom>
+        </p:spPr>
+      </p:pic>
+      <p:sp>
+        <p:nvSpPr>
+          <p:cNvPr id="12" name="CuadroTexto 11">
+            <a:extLst>
+              <a:ext uri="{FF2B5EF4-FFF2-40B4-BE49-F238E27FC236}">
+                <a16:creationId xmlns:a16="http://schemas.microsoft.com/office/drawing/2014/main" id="{8B51CD8C-DB5F-892A-4B92-E56F0244E354}"/>
+              </a:ext>
+            </a:extLst>
+          </p:cNvPr>
+          <p:cNvSpPr txBox="1"/>
+          <p:nvPr/>
+        </p:nvSpPr>
+        <p:spPr>
+          <a:xfrm>
+            <a:off x="8231453" y="321314"/>
+            <a:ext cx="1151431" cy="215444"/>
+          </a:xfrm>
+          <a:prstGeom prst="rect">
+            <a:avLst/>
+          </a:prstGeom>
+          <a:noFill/>
+        </p:spPr>
+        <p:txBody>
+          <a:bodyPr wrap="square" rtlCol="0">
+            <a:spAutoFit/>
+          </a:bodyPr>
+          <a:lstStyle/>
+          <a:p>
+            <a:r>
+              <a:rPr lang="en-GB" sz="800" spc="100" noProof="0" dirty="0">
+                <a:solidFill>
+                  <a:srgbClr val="FF0000"/>
+                </a:solidFill>
+                <a:latin typeface="Aptos Display" panose="020B0004020202020204" pitchFamily="34" charset="0"/>
+              </a:rPr>
+              <a:t>CONFIDENTIAL</a:t>
+            </a:r>
+          </a:p>
+        </p:txBody>
+      </p:sp>
+      <p:sp>
+        <p:nvSpPr>
+          <p:cNvPr id="13" name="TextBox 12"/>
+          <p:cNvSpPr txBox="1"/>
+          <p:nvPr/>
+        </p:nvSpPr>
+        <p:spPr>
+          <a:xfrm>
+            <a:off x="411480" y="850392"/>
+            <a:ext cx="8321040" cy="320040"/>
+          </a:xfrm>
+          <a:prstGeom prst="rect">
+            <a:avLst/>
+          </a:prstGeom>
+          <a:noFill/>
+        </p:spPr>
+        <p:txBody>
+          <a:bodyPr wrap="square" lIns="18288" rIns="18288" tIns="0" bIns="0">
+            <a:spAutoFit/>
+          </a:bodyPr>
+          <a:lstStyle/>
+          <a:p>
+            <a:pPr>
+              <a:spcAft>
+                <a:spcPts val="500"/>
+              </a:spcAft>
+              <a:defRPr sz="1100" b="1">
+                <a:solidFill>
+                  <a:srgbClr val="013EF5"/>
+                </a:solidFill>
+                <a:latin typeface="DejaVu Sans"/>
+              </a:defRPr>
+            </a:pPr>
+            <a:r>
+              <a:t>OCTOBER 2026 · PHOTOS &amp; RELEVANT HIGHLIGHTS · cut-off 27 Oct</a:t>
+            </a:r>
+          </a:p>
+        </p:txBody>
+      </p:sp>
+      <p:sp>
+        <p:nvSpPr>
+          <p:cNvPr id="14" name="Rectangle 13"/>
+          <p:cNvSpPr/>
+          <p:nvPr/>
+        </p:nvSpPr>
+        <p:spPr>
+          <a:xfrm>
+            <a:off x="411480" y="1417320"/>
+            <a:ext cx="4023360" cy="2331720"/>
+          </a:xfrm>
+          <a:prstGeom prst="rect">
+            <a:avLst/>
+          </a:prstGeom>
+          <a:solidFill>
+            <a:srgbClr val="F2F3F5"/>
+          </a:solidFill>
+          <a:ln>
+            <a:solidFill>
+              <a:srgbClr val="CDD2D9"/>
+            </a:solidFill>
+          </a:ln>
+          <a:effectLst/>
+        </p:spPr>
+        <p:style>
+          <a:lnRef idx="1">
+            <a:schemeClr val="accent1"/>
+          </a:lnRef>
+          <a:fillRef idx="3">
+            <a:schemeClr val="accent1"/>
+          </a:fillRef>
+          <a:effectRef idx="2">
+            <a:schemeClr val="accent1"/>
+          </a:effectRef>
+          <a:fontRef idx="minor">
+            <a:schemeClr val="lt1"/>
+          </a:fontRef>
+        </p:style>
+        <p:txBody>
+          <a:bodyPr rtlCol="0" anchor="ctr"/>
+          <a:lstStyle/>
+          <a:p>
+            <a:pPr algn="ctr"/>
+          </a:p>
+        </p:txBody>
+      </p:sp>
+      <p:sp>
+        <p:nvSpPr>
+          <p:cNvPr id="15" name="TextBox 14"/>
+          <p:cNvSpPr txBox="1"/>
+          <p:nvPr/>
+        </p:nvSpPr>
+        <p:spPr>
+          <a:xfrm>
+            <a:off x="548640" y="2148840"/>
+            <a:ext cx="3749039" cy="640080"/>
+          </a:xfrm>
+          <a:prstGeom prst="rect">
+            <a:avLst/>
+          </a:prstGeom>
+          <a:noFill/>
+        </p:spPr>
+        <p:txBody>
+          <a:bodyPr wrap="square" lIns="18288" rIns="18288" tIns="0" bIns="0">
+            <a:spAutoFit/>
+          </a:bodyPr>
+          <a:lstStyle/>
+          <a:p>
+            <a:pPr algn="ctr">
+              <a:spcAft>
+                <a:spcPts val="500"/>
+              </a:spcAft>
+              <a:defRPr sz="1500" b="0">
+                <a:solidFill>
+                  <a:srgbClr val="68717D"/>
+                </a:solidFill>
+                <a:latin typeface="DejaVu Sans"/>
+              </a:defRPr>
+            </a:pPr>
+            <a:r>
+              <a:t>OCTOBER PHOTO 1</a:t>
+            </a:r>
+          </a:p>
+          <a:p>
+            <a:pPr algn="ctr">
+              <a:spcAft>
+                <a:spcPts val="500"/>
+              </a:spcAft>
+              <a:defRPr sz="1500" b="0">
+                <a:solidFill>
+                  <a:srgbClr val="68717D"/>
+                </a:solidFill>
+                <a:latin typeface="DejaVu Sans"/>
+              </a:defRPr>
+            </a:pPr>
+            <a:r>
+              <a:t>Pending actual photo</a:t>
+            </a:r>
+          </a:p>
+        </p:txBody>
+      </p:sp>
+      <p:sp>
+        <p:nvSpPr>
+          <p:cNvPr id="16" name="TextBox 15"/>
+          <p:cNvSpPr txBox="1"/>
+          <p:nvPr/>
+        </p:nvSpPr>
+        <p:spPr>
+          <a:xfrm>
+            <a:off x="411480" y="3867912"/>
+            <a:ext cx="4023360" cy="502920"/>
+          </a:xfrm>
+          <a:prstGeom prst="rect">
+            <a:avLst/>
+          </a:prstGeom>
+          <a:noFill/>
+        </p:spPr>
+        <p:txBody>
+          <a:bodyPr wrap="square" lIns="18288" rIns="18288" tIns="0" bIns="0">
+            <a:spAutoFit/>
+          </a:bodyPr>
+          <a:lstStyle/>
+          <a:p>
+            <a:pPr>
+              <a:spcAft>
+                <a:spcPts val="500"/>
+              </a:spcAft>
+              <a:defRPr sz="950" b="0">
+                <a:solidFill>
+                  <a:srgbClr val="68717D"/>
+                </a:solidFill>
+                <a:latin typeface="DejaVu Sans"/>
+              </a:defRPr>
+            </a:pPr>
+            <a:r>
+              <a:t>Date / location / activity: pending confirmation</a:t>
+            </a:r>
+          </a:p>
+        </p:txBody>
+      </p:sp>
+      <p:sp>
+        <p:nvSpPr>
+          <p:cNvPr id="17" name="Rectangle 16"/>
+          <p:cNvSpPr/>
+          <p:nvPr/>
+        </p:nvSpPr>
+        <p:spPr>
+          <a:xfrm>
+            <a:off x="4681728" y="1417320"/>
+            <a:ext cx="4023360" cy="2331720"/>
+          </a:xfrm>
+          <a:prstGeom prst="rect">
+            <a:avLst/>
+          </a:prstGeom>
+          <a:solidFill>
+            <a:srgbClr val="F2F3F5"/>
+          </a:solidFill>
+          <a:ln>
+            <a:solidFill>
+              <a:srgbClr val="CDD2D9"/>
+            </a:solidFill>
+          </a:ln>
+          <a:effectLst/>
+        </p:spPr>
+        <p:style>
+          <a:lnRef idx="1">
+            <a:schemeClr val="accent1"/>
+          </a:lnRef>
+          <a:fillRef idx="3">
+            <a:schemeClr val="accent1"/>
+          </a:fillRef>
+          <a:effectRef idx="2">
+            <a:schemeClr val="accent1"/>
+          </a:effectRef>
+          <a:fontRef idx="minor">
+            <a:schemeClr val="lt1"/>
+          </a:fontRef>
+        </p:style>
+        <p:txBody>
+          <a:bodyPr rtlCol="0" anchor="ctr"/>
+          <a:lstStyle/>
+          <a:p>
+            <a:pPr algn="ctr"/>
+          </a:p>
+        </p:txBody>
+      </p:sp>
+      <p:sp>
+        <p:nvSpPr>
+          <p:cNvPr id="18" name="TextBox 17"/>
+          <p:cNvSpPr txBox="1"/>
+          <p:nvPr/>
+        </p:nvSpPr>
+        <p:spPr>
+          <a:xfrm>
+            <a:off x="4818888" y="2148840"/>
+            <a:ext cx="3749039" cy="640080"/>
+          </a:xfrm>
+          <a:prstGeom prst="rect">
+            <a:avLst/>
+          </a:prstGeom>
+          <a:noFill/>
+        </p:spPr>
+        <p:txBody>
+          <a:bodyPr wrap="square" lIns="18288" rIns="18288" tIns="0" bIns="0">
+            <a:spAutoFit/>
+          </a:bodyPr>
+          <a:lstStyle/>
+          <a:p>
+            <a:pPr algn="ctr">
+              <a:spcAft>
+                <a:spcPts val="500"/>
+              </a:spcAft>
+              <a:defRPr sz="1500" b="0">
+                <a:solidFill>
+                  <a:srgbClr val="68717D"/>
+                </a:solidFill>
+                <a:latin typeface="DejaVu Sans"/>
+              </a:defRPr>
+            </a:pPr>
+            <a:r>
+              <a:t>OCTOBER PHOTO 2</a:t>
+            </a:r>
+          </a:p>
+          <a:p>
+            <a:pPr algn="ctr">
+              <a:spcAft>
+                <a:spcPts val="500"/>
+              </a:spcAft>
+              <a:defRPr sz="1500" b="0">
+                <a:solidFill>
+                  <a:srgbClr val="68717D"/>
+                </a:solidFill>
+                <a:latin typeface="DejaVu Sans"/>
+              </a:defRPr>
+            </a:pPr>
+            <a:r>
+              <a:t>Pending actual photo</a:t>
+            </a:r>
+          </a:p>
+        </p:txBody>
+      </p:sp>
+      <p:sp>
+        <p:nvSpPr>
+          <p:cNvPr id="19" name="TextBox 18"/>
+          <p:cNvSpPr txBox="1"/>
+          <p:nvPr/>
+        </p:nvSpPr>
+        <p:spPr>
+          <a:xfrm>
+            <a:off x="4681728" y="3867912"/>
+            <a:ext cx="4023360" cy="502920"/>
+          </a:xfrm>
+          <a:prstGeom prst="rect">
+            <a:avLst/>
+          </a:prstGeom>
+          <a:noFill/>
+        </p:spPr>
+        <p:txBody>
+          <a:bodyPr wrap="square" lIns="18288" rIns="18288" tIns="0" bIns="0">
+            <a:spAutoFit/>
+          </a:bodyPr>
+          <a:lstStyle/>
+          <a:p>
+            <a:pPr>
+              <a:spcAft>
+                <a:spcPts val="500"/>
+              </a:spcAft>
+              <a:defRPr sz="950" b="0">
+                <a:solidFill>
+                  <a:srgbClr val="68717D"/>
+                </a:solidFill>
+                <a:latin typeface="DejaVu Sans"/>
+              </a:defRPr>
+            </a:pPr>
+            <a:r>
+              <a:t>Date / location / activity: pending confirmation</a:t>
+            </a:r>
+          </a:p>
+        </p:txBody>
+      </p:sp>
+      <p:sp>
+        <p:nvSpPr>
+          <p:cNvPr id="20" name="Rectangle 19"/>
+          <p:cNvSpPr/>
+          <p:nvPr/>
+        </p:nvSpPr>
+        <p:spPr>
+          <a:xfrm>
+            <a:off x="411480" y="4590288"/>
+            <a:ext cx="8293608" cy="1554480"/>
+          </a:xfrm>
+          <a:prstGeom prst="rect">
+            <a:avLst/>
+          </a:prstGeom>
+          <a:solidFill>
+            <a:srgbClr val="F2F3F5"/>
+          </a:solidFill>
+          <a:ln>
+            <a:noFill/>
+          </a:ln>
+          <a:effectLst/>
+        </p:spPr>
+        <p:style>
+          <a:lnRef idx="1">
+            <a:schemeClr val="accent1"/>
+          </a:lnRef>
+          <a:fillRef idx="3">
+            <a:schemeClr val="accent1"/>
+          </a:fillRef>
+          <a:effectRef idx="2">
+            <a:schemeClr val="accent1"/>
+          </a:effectRef>
+          <a:fontRef idx="minor">
+            <a:schemeClr val="lt1"/>
+          </a:fontRef>
+        </p:style>
+        <p:txBody>
+          <a:bodyPr rtlCol="0" anchor="ctr"/>
+          <a:lstStyle/>
+          <a:p>
+            <a:pPr algn="ctr"/>
+          </a:p>
+        </p:txBody>
+      </p:sp>
+      <p:sp>
+        <p:nvSpPr>
+          <p:cNvPr id="21" name="TextBox 20"/>
+          <p:cNvSpPr txBox="1"/>
+          <p:nvPr/>
+        </p:nvSpPr>
+        <p:spPr>
+          <a:xfrm>
+            <a:off x="566928" y="4727448"/>
+            <a:ext cx="8001000" cy="274320"/>
+          </a:xfrm>
+          <a:prstGeom prst="rect">
+            <a:avLst/>
+          </a:prstGeom>
+          <a:noFill/>
+        </p:spPr>
+        <p:txBody>
+          <a:bodyPr wrap="square" lIns="18288" rIns="18288" tIns="0" bIns="0">
+            <a:spAutoFit/>
+          </a:bodyPr>
+          <a:lstStyle/>
+          <a:p>
+            <a:pPr>
+              <a:spcAft>
+                <a:spcPts val="500"/>
+              </a:spcAft>
+              <a:defRPr sz="1200" b="1">
+                <a:solidFill>
+                  <a:srgbClr val="013EF5"/>
+                </a:solidFill>
+                <a:latin typeface="DejaVu Sans"/>
+              </a:defRPr>
+            </a:pPr>
+            <a:r>
+              <a:t>ENVIRONMENT — RELEVANT OCTOBER TOPICS</a:t>
+            </a:r>
+          </a:p>
+        </p:txBody>
+      </p:sp>
+      <p:sp>
+        <p:nvSpPr>
+          <p:cNvPr id="22" name="TextBox 21"/>
+          <p:cNvSpPr txBox="1"/>
+          <p:nvPr/>
+        </p:nvSpPr>
+        <p:spPr>
+          <a:xfrm>
+            <a:off x="566928" y="5184648"/>
+            <a:ext cx="7863840" cy="749808"/>
+          </a:xfrm>
+          <a:prstGeom prst="rect">
+            <a:avLst/>
+          </a:prstGeom>
+          <a:noFill/>
+        </p:spPr>
+        <p:txBody>
+          <a:bodyPr wrap="square" lIns="18288" rIns="18288" tIns="0" bIns="0">
+            <a:spAutoFit/>
+          </a:bodyPr>
+          <a:lstStyle/>
+          <a:p>
+            <a:pPr>
+              <a:spcAft>
+                <a:spcPts val="500"/>
+              </a:spcAft>
+              <a:defRPr sz="1200" b="0">
+                <a:solidFill>
+                  <a:srgbClr val="27364A"/>
+                </a:solidFill>
+                <a:latin typeface="DejaVu Sans"/>
+              </a:defRPr>
+            </a:pPr>
+            <a:r>
+              <a:t>[Pending topics from Leandro Doglio]</a:t>
+            </a:r>
+          </a:p>
+          <a:p>
+            <a:pPr>
+              <a:spcAft>
+                <a:spcPts val="500"/>
+              </a:spcAft>
+              <a:defRPr sz="1200" b="0">
+                <a:solidFill>
+                  <a:srgbClr val="27364A"/>
+                </a:solidFill>
+                <a:latin typeface="DejaVu Sans"/>
+              </a:defRPr>
+            </a:pPr>
+            <a:r>
+              <a:t>Confirmed development · relevance · next step</a:t>
+            </a:r>
+          </a:p>
+        </p:txBody>
+      </p:sp>
+      <p:sp>
+        <p:nvSpPr>
+          <p:cNvPr id="23" name="TextBox 22"/>
+          <p:cNvSpPr txBox="1"/>
+          <p:nvPr/>
+        </p:nvSpPr>
+        <p:spPr>
+          <a:xfrm>
+            <a:off x="3474720" y="6601968"/>
+            <a:ext cx="4389120" cy="155448"/>
+          </a:xfrm>
+          <a:prstGeom prst="rect">
+            <a:avLst/>
+          </a:prstGeom>
+          <a:noFill/>
+        </p:spPr>
+        <p:txBody>
+          <a:bodyPr wrap="square" lIns="18288" rIns="18288" tIns="0" bIns="0">
+            <a:spAutoFit/>
+          </a:bodyPr>
+          <a:lstStyle/>
+          <a:p>
+            <a:pPr>
+              <a:spcAft>
+                <a:spcPts val="500"/>
+              </a:spcAft>
+              <a:defRPr sz="650" b="0">
+                <a:solidFill>
+                  <a:srgbClr val="68717D"/>
+                </a:solidFill>
+                <a:latin typeface="DejaVu Sans"/>
+              </a:defRPr>
+            </a:pPr>
+            <a:r>
+              <a:t>WORKING DRAFT · October topics pending</a:t>
+            </a:r>
+          </a:p>
+        </p:txBody>
+      </p:sp>
+      <p:sp>
+        <p:nvSpPr>
+          <p:cNvPr id="24" name="TextBox 23"/>
+          <p:cNvSpPr txBox="1"/>
+          <p:nvPr/>
+        </p:nvSpPr>
+        <p:spPr>
+          <a:xfrm>
+            <a:off x="8595360" y="6556248"/>
+            <a:ext cx="274320" cy="201168"/>
+          </a:xfrm>
+          <a:prstGeom prst="rect">
+            <a:avLst/>
+          </a:prstGeom>
+          <a:noFill/>
+        </p:spPr>
+        <p:txBody>
+          <a:bodyPr wrap="square" lIns="18288" rIns="18288" tIns="0" bIns="0">
+            <a:spAutoFit/>
+          </a:bodyPr>
+          <a:lstStyle/>
+          <a:p>
+            <a:pPr algn="r">
+              <a:spcAft>
+                <a:spcPts val="500"/>
+              </a:spcAft>
+              <a:defRPr sz="800" b="0">
+                <a:solidFill>
+                  <a:srgbClr val="68717D"/>
+                </a:solidFill>
+                <a:latin typeface="DejaVu Sans"/>
+              </a:defRPr>
+            </a:pPr>
+            <a:r>
+              <a:t>7</a:t>
+            </a:r>
+          </a:p>
+        </p:txBody>
+      </p:sp>
+    </p:spTree>
+  </p:cSld>
+  <p:clrMapOvr>
+    <a:masterClrMapping/>
+  </p:clrMapOvr>
+</p:sld>
+</file>
+
+<file path=ppt/slides/slide8.xml><?xml version="1.0" encoding="utf-8"?>
 <p:sld xmlns:a="http://schemas.openxmlformats.org/drawingml/2006/main" xmlns:r="http://schemas.openxmlformats.org/officeDocument/2006/relationships" xmlns:p="http://schemas.openxmlformats.org/presentationml/2006/main">
   <p:cSld>
     <p:spTree>
@@ -12073,7 +14306,7 @@
 </p:sld>
 </file>
 
-<file path=ppt/slides/slide6.xml><?xml version="1.0" encoding="utf-8"?>
+<file path=ppt/slides/slide9.xml><?xml version="1.0" encoding="utf-8"?>
 <p:sld xmlns:a="http://schemas.openxmlformats.org/drawingml/2006/main" xmlns:r="http://schemas.openxmlformats.org/officeDocument/2006/relationships" xmlns:p="http://schemas.openxmlformats.org/presentationml/2006/main">
   <p:cSld>
     <p:spTree>
@@ -12561,2233 +14794,6 @@
         <p14:creationId xmlns:p14="http://schemas.microsoft.com/office/powerpoint/2010/main" val="4069171775"/>
       </p:ext>
     </p:extLst>
-  </p:cSld>
-  <p:clrMapOvr>
-    <a:masterClrMapping/>
-  </p:clrMapOvr>
-</p:sld>
-</file>
-
-<file path=ppt/slides/slide7.xml><?xml version="1.0" encoding="utf-8"?>
-<p:sld xmlns:a="http://schemas.openxmlformats.org/drawingml/2006/main" xmlns:p="http://schemas.openxmlformats.org/presentationml/2006/main" xmlns:r="http://schemas.openxmlformats.org/officeDocument/2006/relationships">
-  <p:cSld>
-    <p:spTree>
-      <p:nvGrpSpPr>
-        <p:cNvPr id="1" name=""/>
-        <p:cNvGrpSpPr/>
-        <p:nvPr/>
-      </p:nvGrpSpPr>
-      <p:grpSpPr/>
-      <p:sp>
-        <p:nvSpPr>
-          <p:cNvPr id="8" name="Rectángulo 7">
-            <a:extLst>
-              <a:ext uri="{FF2B5EF4-FFF2-40B4-BE49-F238E27FC236}">
-                <a16:creationId xmlns:a16="http://schemas.microsoft.com/office/drawing/2014/main" id="{E0F0ACF1-FB3B-891E-E4C9-CEDACE965B70}"/>
-              </a:ext>
-            </a:extLst>
-          </p:cNvPr>
-          <p:cNvSpPr/>
-          <p:nvPr/>
-        </p:nvSpPr>
-        <p:spPr>
-          <a:xfrm>
-            <a:off x="0" y="0"/>
-            <a:ext cx="9144000" cy="706582"/>
-          </a:xfrm>
-          <a:prstGeom prst="rect">
-            <a:avLst/>
-          </a:prstGeom>
-          <a:solidFill>
-            <a:schemeClr val="bg1">
-              <a:lumMod val="95000"/>
-            </a:schemeClr>
-          </a:solidFill>
-          <a:ln>
-            <a:noFill/>
-          </a:ln>
-        </p:spPr>
-        <p:style>
-          <a:lnRef idx="2">
-            <a:schemeClr val="accent1">
-              <a:shade val="50000"/>
-            </a:schemeClr>
-          </a:lnRef>
-          <a:fillRef idx="1">
-            <a:schemeClr val="accent1"/>
-          </a:fillRef>
-          <a:effectRef idx="0">
-            <a:schemeClr val="accent1"/>
-          </a:effectRef>
-          <a:fontRef idx="minor">
-            <a:schemeClr val="lt1"/>
-          </a:fontRef>
-        </p:style>
-        <p:txBody>
-          <a:bodyPr rtlCol="0" anchor="ctr"/>
-          <a:lstStyle/>
-          <a:p>
-            <a:pPr algn="ctr"/>
-            <a:endParaRPr lang="en-GB" noProof="0" dirty="0"/>
-          </a:p>
-        </p:txBody>
-      </p:sp>
-      <p:sp>
-        <p:nvSpPr>
-          <p:cNvPr id="9" name="Título 1">
-            <a:extLst>
-              <a:ext uri="{FF2B5EF4-FFF2-40B4-BE49-F238E27FC236}">
-                <a16:creationId xmlns:a16="http://schemas.microsoft.com/office/drawing/2014/main" id="{2C399A2C-904E-A0D7-BF10-0536804170B1}"/>
-              </a:ext>
-            </a:extLst>
-          </p:cNvPr>
-          <p:cNvSpPr txBox="1">
-            <a:spLocks/>
-          </p:cNvSpPr>
-          <p:nvPr/>
-        </p:nvSpPr>
-        <p:spPr>
-          <a:xfrm>
-            <a:off x="179509" y="142504"/>
-            <a:ext cx="7863840" cy="475488"/>
-          </a:xfrm>
-          <a:prstGeom prst="rect">
-            <a:avLst/>
-          </a:prstGeom>
-        </p:spPr>
-        <p:txBody>
-          <a:bodyPr vert="horz" lIns="91440" tIns="45720" rIns="91440" bIns="45720" rtlCol="0" anchor="ctr">
-            <a:normAutofit/>
-          </a:bodyPr>
-          <a:lstStyle>
-            <a:lvl1pPr algn="ctr" defTabSz="914400" rtl="0" eaLnBrk="1" latinLnBrk="0" hangingPunct="1">
-              <a:spcBef>
-                <a:spcPct val="0"/>
-              </a:spcBef>
-              <a:buNone/>
-              <a:defRPr sz="4400" kern="1200">
-                <a:solidFill>
-                  <a:schemeClr val="tx1"/>
-                </a:solidFill>
-                <a:latin typeface="+mj-lt"/>
-                <a:ea typeface="+mj-ea"/>
-                <a:cs typeface="+mj-cs"/>
-              </a:defRPr>
-            </a:lvl1pPr>
-          </a:lstStyle>
-          <a:p>
-            <a:pPr algn="l"/>
-            <a:r>
-              <a:rPr sz="1400" b="1">
-                <a:solidFill>
-                  <a:srgbClr val="013EF5"/>
-                </a:solidFill>
-                <a:latin typeface="DejaVu Sans"/>
-              </a:rPr>
-              <a:t>1.1 &gt; DEDICATED GAS PIPELINE UPDATE &gt; Safety | October Highlights</a:t>
-            </a:r>
-          </a:p>
-        </p:txBody>
-      </p:sp>
-      <p:pic>
-        <p:nvPicPr>
-          <p:cNvPr id="11" name="Imagen 10">
-            <a:extLst>
-              <a:ext uri="{FF2B5EF4-FFF2-40B4-BE49-F238E27FC236}">
-                <a16:creationId xmlns:a16="http://schemas.microsoft.com/office/drawing/2014/main" id="{B890EEC0-89A1-F0FA-6F0E-CA480F8EF46C}"/>
-              </a:ext>
-            </a:extLst>
-          </p:cNvPr>
-          <p:cNvPicPr>
-            <a:picLocks noChangeAspect="1"/>
-          </p:cNvPicPr>
-          <p:nvPr/>
-        </p:nvPicPr>
-        <p:blipFill rotWithShape="1">
-          <a:blip r:embed="rId2"/>
-          <a:srcRect t="-1" r="54800" b="49955"/>
-          <a:stretch/>
-        </p:blipFill>
-        <p:spPr>
-          <a:xfrm>
-            <a:off x="8549908" y="117682"/>
-            <a:ext cx="274715" cy="232529"/>
-          </a:xfrm>
-          <a:prstGeom prst="rect">
-            <a:avLst/>
-          </a:prstGeom>
-        </p:spPr>
-      </p:pic>
-      <p:sp>
-        <p:nvSpPr>
-          <p:cNvPr id="12" name="CuadroTexto 11">
-            <a:extLst>
-              <a:ext uri="{FF2B5EF4-FFF2-40B4-BE49-F238E27FC236}">
-                <a16:creationId xmlns:a16="http://schemas.microsoft.com/office/drawing/2014/main" id="{8B51CD8C-DB5F-892A-4B92-E56F0244E354}"/>
-              </a:ext>
-            </a:extLst>
-          </p:cNvPr>
-          <p:cNvSpPr txBox="1"/>
-          <p:nvPr/>
-        </p:nvSpPr>
-        <p:spPr>
-          <a:xfrm>
-            <a:off x="8231453" y="321314"/>
-            <a:ext cx="1151431" cy="215444"/>
-          </a:xfrm>
-          <a:prstGeom prst="rect">
-            <a:avLst/>
-          </a:prstGeom>
-          <a:noFill/>
-        </p:spPr>
-        <p:txBody>
-          <a:bodyPr wrap="square" rtlCol="0">
-            <a:spAutoFit/>
-          </a:bodyPr>
-          <a:lstStyle/>
-          <a:p>
-            <a:r>
-              <a:rPr lang="en-GB" sz="800" spc="100" noProof="0" dirty="0">
-                <a:solidFill>
-                  <a:srgbClr val="FF0000"/>
-                </a:solidFill>
-                <a:latin typeface="Aptos Display" panose="020B0004020202020204" pitchFamily="34" charset="0"/>
-              </a:rPr>
-              <a:t>CONFIDENTIAL</a:t>
-            </a:r>
-          </a:p>
-        </p:txBody>
-      </p:sp>
-      <p:sp>
-        <p:nvSpPr>
-          <p:cNvPr id="13" name="TextBox 12"/>
-          <p:cNvSpPr txBox="1"/>
-          <p:nvPr/>
-        </p:nvSpPr>
-        <p:spPr>
-          <a:xfrm>
-            <a:off x="411480" y="850392"/>
-            <a:ext cx="8321040" cy="320040"/>
-          </a:xfrm>
-          <a:prstGeom prst="rect">
-            <a:avLst/>
-          </a:prstGeom>
-          <a:noFill/>
-        </p:spPr>
-        <p:txBody>
-          <a:bodyPr wrap="square" lIns="18288" rIns="18288" tIns="0" bIns="0">
-            <a:spAutoFit/>
-          </a:bodyPr>
-          <a:lstStyle/>
-          <a:p>
-            <a:pPr>
-              <a:spcAft>
-                <a:spcPts val="500"/>
-              </a:spcAft>
-              <a:defRPr sz="1100" b="1">
-                <a:solidFill>
-                  <a:srgbClr val="013EF5"/>
-                </a:solidFill>
-                <a:latin typeface="DejaVu Sans"/>
-              </a:defRPr>
-            </a:pPr>
-            <a:r>
-              <a:t>OCTOBER 2026 · PHOTOS &amp; RELEVANT HIGHLIGHTS · cut-off 27 Oct</a:t>
-            </a:r>
-          </a:p>
-        </p:txBody>
-      </p:sp>
-      <p:sp>
-        <p:nvSpPr>
-          <p:cNvPr id="14" name="Rectangle 13"/>
-          <p:cNvSpPr/>
-          <p:nvPr/>
-        </p:nvSpPr>
-        <p:spPr>
-          <a:xfrm>
-            <a:off x="411480" y="1417320"/>
-            <a:ext cx="4023360" cy="2331720"/>
-          </a:xfrm>
-          <a:prstGeom prst="rect">
-            <a:avLst/>
-          </a:prstGeom>
-          <a:solidFill>
-            <a:srgbClr val="F2F3F5"/>
-          </a:solidFill>
-          <a:ln>
-            <a:solidFill>
-              <a:srgbClr val="CDD2D9"/>
-            </a:solidFill>
-          </a:ln>
-          <a:effectLst/>
-        </p:spPr>
-        <p:style>
-          <a:lnRef idx="1">
-            <a:schemeClr val="accent1"/>
-          </a:lnRef>
-          <a:fillRef idx="3">
-            <a:schemeClr val="accent1"/>
-          </a:fillRef>
-          <a:effectRef idx="2">
-            <a:schemeClr val="accent1"/>
-          </a:effectRef>
-          <a:fontRef idx="minor">
-            <a:schemeClr val="lt1"/>
-          </a:fontRef>
-        </p:style>
-        <p:txBody>
-          <a:bodyPr rtlCol="0" anchor="ctr"/>
-          <a:lstStyle/>
-          <a:p>
-            <a:pPr algn="ctr"/>
-          </a:p>
-        </p:txBody>
-      </p:sp>
-      <p:sp>
-        <p:nvSpPr>
-          <p:cNvPr id="15" name="TextBox 14"/>
-          <p:cNvSpPr txBox="1"/>
-          <p:nvPr/>
-        </p:nvSpPr>
-        <p:spPr>
-          <a:xfrm>
-            <a:off x="548640" y="2148840"/>
-            <a:ext cx="3749039" cy="640080"/>
-          </a:xfrm>
-          <a:prstGeom prst="rect">
-            <a:avLst/>
-          </a:prstGeom>
-          <a:noFill/>
-        </p:spPr>
-        <p:txBody>
-          <a:bodyPr wrap="square" lIns="18288" rIns="18288" tIns="0" bIns="0">
-            <a:spAutoFit/>
-          </a:bodyPr>
-          <a:lstStyle/>
-          <a:p>
-            <a:pPr algn="ctr">
-              <a:spcAft>
-                <a:spcPts val="500"/>
-              </a:spcAft>
-              <a:defRPr sz="1500" b="0">
-                <a:solidFill>
-                  <a:srgbClr val="68717D"/>
-                </a:solidFill>
-                <a:latin typeface="DejaVu Sans"/>
-              </a:defRPr>
-            </a:pPr>
-            <a:r>
-              <a:t>OCTOBER PHOTO 1</a:t>
-            </a:r>
-          </a:p>
-          <a:p>
-            <a:pPr algn="ctr">
-              <a:spcAft>
-                <a:spcPts val="500"/>
-              </a:spcAft>
-              <a:defRPr sz="1500" b="0">
-                <a:solidFill>
-                  <a:srgbClr val="68717D"/>
-                </a:solidFill>
-                <a:latin typeface="DejaVu Sans"/>
-              </a:defRPr>
-            </a:pPr>
-            <a:r>
-              <a:t>Pending actual photo</a:t>
-            </a:r>
-          </a:p>
-        </p:txBody>
-      </p:sp>
-      <p:sp>
-        <p:nvSpPr>
-          <p:cNvPr id="16" name="TextBox 15"/>
-          <p:cNvSpPr txBox="1"/>
-          <p:nvPr/>
-        </p:nvSpPr>
-        <p:spPr>
-          <a:xfrm>
-            <a:off x="411480" y="3867912"/>
-            <a:ext cx="4023360" cy="502920"/>
-          </a:xfrm>
-          <a:prstGeom prst="rect">
-            <a:avLst/>
-          </a:prstGeom>
-          <a:noFill/>
-        </p:spPr>
-        <p:txBody>
-          <a:bodyPr wrap="square" lIns="18288" rIns="18288" tIns="0" bIns="0">
-            <a:spAutoFit/>
-          </a:bodyPr>
-          <a:lstStyle/>
-          <a:p>
-            <a:pPr>
-              <a:spcAft>
-                <a:spcPts val="500"/>
-              </a:spcAft>
-              <a:defRPr sz="950" b="0">
-                <a:solidFill>
-                  <a:srgbClr val="68717D"/>
-                </a:solidFill>
-                <a:latin typeface="DejaVu Sans"/>
-              </a:defRPr>
-            </a:pPr>
-            <a:r>
-              <a:t>Date / location / activity: pending confirmation</a:t>
-            </a:r>
-          </a:p>
-        </p:txBody>
-      </p:sp>
-      <p:sp>
-        <p:nvSpPr>
-          <p:cNvPr id="17" name="Rectangle 16"/>
-          <p:cNvSpPr/>
-          <p:nvPr/>
-        </p:nvSpPr>
-        <p:spPr>
-          <a:xfrm>
-            <a:off x="4681728" y="1417320"/>
-            <a:ext cx="4023360" cy="2331720"/>
-          </a:xfrm>
-          <a:prstGeom prst="rect">
-            <a:avLst/>
-          </a:prstGeom>
-          <a:solidFill>
-            <a:srgbClr val="F2F3F5"/>
-          </a:solidFill>
-          <a:ln>
-            <a:solidFill>
-              <a:srgbClr val="CDD2D9"/>
-            </a:solidFill>
-          </a:ln>
-          <a:effectLst/>
-        </p:spPr>
-        <p:style>
-          <a:lnRef idx="1">
-            <a:schemeClr val="accent1"/>
-          </a:lnRef>
-          <a:fillRef idx="3">
-            <a:schemeClr val="accent1"/>
-          </a:fillRef>
-          <a:effectRef idx="2">
-            <a:schemeClr val="accent1"/>
-          </a:effectRef>
-          <a:fontRef idx="minor">
-            <a:schemeClr val="lt1"/>
-          </a:fontRef>
-        </p:style>
-        <p:txBody>
-          <a:bodyPr rtlCol="0" anchor="ctr"/>
-          <a:lstStyle/>
-          <a:p>
-            <a:pPr algn="ctr"/>
-          </a:p>
-        </p:txBody>
-      </p:sp>
-      <p:sp>
-        <p:nvSpPr>
-          <p:cNvPr id="18" name="TextBox 17"/>
-          <p:cNvSpPr txBox="1"/>
-          <p:nvPr/>
-        </p:nvSpPr>
-        <p:spPr>
-          <a:xfrm>
-            <a:off x="4818888" y="2148840"/>
-            <a:ext cx="3749039" cy="640080"/>
-          </a:xfrm>
-          <a:prstGeom prst="rect">
-            <a:avLst/>
-          </a:prstGeom>
-          <a:noFill/>
-        </p:spPr>
-        <p:txBody>
-          <a:bodyPr wrap="square" lIns="18288" rIns="18288" tIns="0" bIns="0">
-            <a:spAutoFit/>
-          </a:bodyPr>
-          <a:lstStyle/>
-          <a:p>
-            <a:pPr algn="ctr">
-              <a:spcAft>
-                <a:spcPts val="500"/>
-              </a:spcAft>
-              <a:defRPr sz="1500" b="0">
-                <a:solidFill>
-                  <a:srgbClr val="68717D"/>
-                </a:solidFill>
-                <a:latin typeface="DejaVu Sans"/>
-              </a:defRPr>
-            </a:pPr>
-            <a:r>
-              <a:t>OCTOBER PHOTO 2</a:t>
-            </a:r>
-          </a:p>
-          <a:p>
-            <a:pPr algn="ctr">
-              <a:spcAft>
-                <a:spcPts val="500"/>
-              </a:spcAft>
-              <a:defRPr sz="1500" b="0">
-                <a:solidFill>
-                  <a:srgbClr val="68717D"/>
-                </a:solidFill>
-                <a:latin typeface="DejaVu Sans"/>
-              </a:defRPr>
-            </a:pPr>
-            <a:r>
-              <a:t>Pending actual photo</a:t>
-            </a:r>
-          </a:p>
-        </p:txBody>
-      </p:sp>
-      <p:sp>
-        <p:nvSpPr>
-          <p:cNvPr id="19" name="TextBox 18"/>
-          <p:cNvSpPr txBox="1"/>
-          <p:nvPr/>
-        </p:nvSpPr>
-        <p:spPr>
-          <a:xfrm>
-            <a:off x="4681728" y="3867912"/>
-            <a:ext cx="4023360" cy="502920"/>
-          </a:xfrm>
-          <a:prstGeom prst="rect">
-            <a:avLst/>
-          </a:prstGeom>
-          <a:noFill/>
-        </p:spPr>
-        <p:txBody>
-          <a:bodyPr wrap="square" lIns="18288" rIns="18288" tIns="0" bIns="0">
-            <a:spAutoFit/>
-          </a:bodyPr>
-          <a:lstStyle/>
-          <a:p>
-            <a:pPr>
-              <a:spcAft>
-                <a:spcPts val="500"/>
-              </a:spcAft>
-              <a:defRPr sz="950" b="0">
-                <a:solidFill>
-                  <a:srgbClr val="68717D"/>
-                </a:solidFill>
-                <a:latin typeface="DejaVu Sans"/>
-              </a:defRPr>
-            </a:pPr>
-            <a:r>
-              <a:t>Date / location / activity: pending confirmation</a:t>
-            </a:r>
-          </a:p>
-        </p:txBody>
-      </p:sp>
-      <p:sp>
-        <p:nvSpPr>
-          <p:cNvPr id="20" name="Rectangle 19"/>
-          <p:cNvSpPr/>
-          <p:nvPr/>
-        </p:nvSpPr>
-        <p:spPr>
-          <a:xfrm>
-            <a:off x="411480" y="4590288"/>
-            <a:ext cx="8293608" cy="1554480"/>
-          </a:xfrm>
-          <a:prstGeom prst="rect">
-            <a:avLst/>
-          </a:prstGeom>
-          <a:solidFill>
-            <a:srgbClr val="F2F3F5"/>
-          </a:solidFill>
-          <a:ln>
-            <a:noFill/>
-          </a:ln>
-          <a:effectLst/>
-        </p:spPr>
-        <p:style>
-          <a:lnRef idx="1">
-            <a:schemeClr val="accent1"/>
-          </a:lnRef>
-          <a:fillRef idx="3">
-            <a:schemeClr val="accent1"/>
-          </a:fillRef>
-          <a:effectRef idx="2">
-            <a:schemeClr val="accent1"/>
-          </a:effectRef>
-          <a:fontRef idx="minor">
-            <a:schemeClr val="lt1"/>
-          </a:fontRef>
-        </p:style>
-        <p:txBody>
-          <a:bodyPr rtlCol="0" anchor="ctr"/>
-          <a:lstStyle/>
-          <a:p>
-            <a:pPr algn="ctr"/>
-          </a:p>
-        </p:txBody>
-      </p:sp>
-      <p:sp>
-        <p:nvSpPr>
-          <p:cNvPr id="21" name="TextBox 20"/>
-          <p:cNvSpPr txBox="1"/>
-          <p:nvPr/>
-        </p:nvSpPr>
-        <p:spPr>
-          <a:xfrm>
-            <a:off x="566928" y="4727448"/>
-            <a:ext cx="8001000" cy="274320"/>
-          </a:xfrm>
-          <a:prstGeom prst="rect">
-            <a:avLst/>
-          </a:prstGeom>
-          <a:noFill/>
-        </p:spPr>
-        <p:txBody>
-          <a:bodyPr wrap="square" lIns="18288" rIns="18288" tIns="0" bIns="0">
-            <a:spAutoFit/>
-          </a:bodyPr>
-          <a:lstStyle/>
-          <a:p>
-            <a:pPr>
-              <a:spcAft>
-                <a:spcPts val="500"/>
-              </a:spcAft>
-              <a:defRPr sz="1200" b="1">
-                <a:solidFill>
-                  <a:srgbClr val="013EF5"/>
-                </a:solidFill>
-                <a:latin typeface="DejaVu Sans"/>
-              </a:defRPr>
-            </a:pPr>
-            <a:r>
-              <a:t>SAFETY — RELEVANT OCTOBER TOPICS</a:t>
-            </a:r>
-          </a:p>
-        </p:txBody>
-      </p:sp>
-      <p:sp>
-        <p:nvSpPr>
-          <p:cNvPr id="22" name="TextBox 21"/>
-          <p:cNvSpPr txBox="1"/>
-          <p:nvPr/>
-        </p:nvSpPr>
-        <p:spPr>
-          <a:xfrm>
-            <a:off x="566928" y="5184648"/>
-            <a:ext cx="7863840" cy="749808"/>
-          </a:xfrm>
-          <a:prstGeom prst="rect">
-            <a:avLst/>
-          </a:prstGeom>
-          <a:noFill/>
-        </p:spPr>
-        <p:txBody>
-          <a:bodyPr wrap="square" lIns="18288" rIns="18288" tIns="0" bIns="0">
-            <a:spAutoFit/>
-          </a:bodyPr>
-          <a:lstStyle/>
-          <a:p>
-            <a:pPr>
-              <a:spcAft>
-                <a:spcPts val="500"/>
-              </a:spcAft>
-              <a:defRPr sz="1200" b="0">
-                <a:solidFill>
-                  <a:srgbClr val="27364A"/>
-                </a:solidFill>
-                <a:latin typeface="DejaVu Sans"/>
-              </a:defRPr>
-            </a:pPr>
-            <a:r>
-              <a:t>[Pending topics from Leandro Doglio]</a:t>
-            </a:r>
-          </a:p>
-          <a:p>
-            <a:pPr>
-              <a:spcAft>
-                <a:spcPts val="500"/>
-              </a:spcAft>
-              <a:defRPr sz="1200" b="0">
-                <a:solidFill>
-                  <a:srgbClr val="27364A"/>
-                </a:solidFill>
-                <a:latin typeface="DejaVu Sans"/>
-              </a:defRPr>
-            </a:pPr>
-            <a:r>
-              <a:t>Confirmed development · relevance · next step</a:t>
-            </a:r>
-          </a:p>
-        </p:txBody>
-      </p:sp>
-      <p:sp>
-        <p:nvSpPr>
-          <p:cNvPr id="23" name="TextBox 22"/>
-          <p:cNvSpPr txBox="1"/>
-          <p:nvPr/>
-        </p:nvSpPr>
-        <p:spPr>
-          <a:xfrm>
-            <a:off x="3474720" y="6601968"/>
-            <a:ext cx="4389120" cy="155448"/>
-          </a:xfrm>
-          <a:prstGeom prst="rect">
-            <a:avLst/>
-          </a:prstGeom>
-          <a:noFill/>
-        </p:spPr>
-        <p:txBody>
-          <a:bodyPr wrap="square" lIns="18288" rIns="18288" tIns="0" bIns="0">
-            <a:spAutoFit/>
-          </a:bodyPr>
-          <a:lstStyle/>
-          <a:p>
-            <a:pPr>
-              <a:spcAft>
-                <a:spcPts val="500"/>
-              </a:spcAft>
-              <a:defRPr sz="650" b="0">
-                <a:solidFill>
-                  <a:srgbClr val="68717D"/>
-                </a:solidFill>
-                <a:latin typeface="DejaVu Sans"/>
-              </a:defRPr>
-            </a:pPr>
-            <a:r>
-              <a:t>WORKING DRAFT · October topics pending</a:t>
-            </a:r>
-          </a:p>
-        </p:txBody>
-      </p:sp>
-      <p:sp>
-        <p:nvSpPr>
-          <p:cNvPr id="24" name="TextBox 23"/>
-          <p:cNvSpPr txBox="1"/>
-          <p:nvPr/>
-        </p:nvSpPr>
-        <p:spPr>
-          <a:xfrm>
-            <a:off x="8595360" y="6556248"/>
-            <a:ext cx="274320" cy="201168"/>
-          </a:xfrm>
-          <a:prstGeom prst="rect">
-            <a:avLst/>
-          </a:prstGeom>
-          <a:noFill/>
-        </p:spPr>
-        <p:txBody>
-          <a:bodyPr wrap="square" lIns="18288" rIns="18288" tIns="0" bIns="0">
-            <a:spAutoFit/>
-          </a:bodyPr>
-          <a:lstStyle/>
-          <a:p>
-            <a:pPr algn="r">
-              <a:spcAft>
-                <a:spcPts val="500"/>
-              </a:spcAft>
-              <a:defRPr sz="800" b="0">
-                <a:solidFill>
-                  <a:srgbClr val="68717D"/>
-                </a:solidFill>
-                <a:latin typeface="DejaVu Sans"/>
-              </a:defRPr>
-            </a:pPr>
-            <a:r>
-              <a:t>5</a:t>
-            </a:r>
-          </a:p>
-        </p:txBody>
-      </p:sp>
-    </p:spTree>
-  </p:cSld>
-  <p:clrMapOvr>
-    <a:masterClrMapping/>
-  </p:clrMapOvr>
-</p:sld>
-</file>
-
-<file path=ppt/slides/slide8.xml><?xml version="1.0" encoding="utf-8"?>
-<p:sld xmlns:a="http://schemas.openxmlformats.org/drawingml/2006/main" xmlns:p="http://schemas.openxmlformats.org/presentationml/2006/main" xmlns:r="http://schemas.openxmlformats.org/officeDocument/2006/relationships">
-  <p:cSld>
-    <p:spTree>
-      <p:nvGrpSpPr>
-        <p:cNvPr id="1" name=""/>
-        <p:cNvGrpSpPr/>
-        <p:nvPr/>
-      </p:nvGrpSpPr>
-      <p:grpSpPr/>
-      <p:sp>
-        <p:nvSpPr>
-          <p:cNvPr id="8" name="Rectángulo 7">
-            <a:extLst>
-              <a:ext uri="{FF2B5EF4-FFF2-40B4-BE49-F238E27FC236}">
-                <a16:creationId xmlns:a16="http://schemas.microsoft.com/office/drawing/2014/main" id="{E0F0ACF1-FB3B-891E-E4C9-CEDACE965B70}"/>
-              </a:ext>
-            </a:extLst>
-          </p:cNvPr>
-          <p:cNvSpPr/>
-          <p:nvPr/>
-        </p:nvSpPr>
-        <p:spPr>
-          <a:xfrm>
-            <a:off x="0" y="0"/>
-            <a:ext cx="9144000" cy="706582"/>
-          </a:xfrm>
-          <a:prstGeom prst="rect">
-            <a:avLst/>
-          </a:prstGeom>
-          <a:solidFill>
-            <a:schemeClr val="bg1">
-              <a:lumMod val="95000"/>
-            </a:schemeClr>
-          </a:solidFill>
-          <a:ln>
-            <a:noFill/>
-          </a:ln>
-        </p:spPr>
-        <p:style>
-          <a:lnRef idx="2">
-            <a:schemeClr val="accent1">
-              <a:shade val="50000"/>
-            </a:schemeClr>
-          </a:lnRef>
-          <a:fillRef idx="1">
-            <a:schemeClr val="accent1"/>
-          </a:fillRef>
-          <a:effectRef idx="0">
-            <a:schemeClr val="accent1"/>
-          </a:effectRef>
-          <a:fontRef idx="minor">
-            <a:schemeClr val="lt1"/>
-          </a:fontRef>
-        </p:style>
-        <p:txBody>
-          <a:bodyPr rtlCol="0" anchor="ctr"/>
-          <a:lstStyle/>
-          <a:p>
-            <a:pPr algn="ctr"/>
-            <a:endParaRPr lang="en-GB" noProof="0" dirty="0"/>
-          </a:p>
-        </p:txBody>
-      </p:sp>
-      <p:sp>
-        <p:nvSpPr>
-          <p:cNvPr id="9" name="Título 1">
-            <a:extLst>
-              <a:ext uri="{FF2B5EF4-FFF2-40B4-BE49-F238E27FC236}">
-                <a16:creationId xmlns:a16="http://schemas.microsoft.com/office/drawing/2014/main" id="{2C399A2C-904E-A0D7-BF10-0536804170B1}"/>
-              </a:ext>
-            </a:extLst>
-          </p:cNvPr>
-          <p:cNvSpPr txBox="1">
-            <a:spLocks/>
-          </p:cNvSpPr>
-          <p:nvPr/>
-        </p:nvSpPr>
-        <p:spPr>
-          <a:xfrm>
-            <a:off x="179509" y="142504"/>
-            <a:ext cx="7863840" cy="475488"/>
-          </a:xfrm>
-          <a:prstGeom prst="rect">
-            <a:avLst/>
-          </a:prstGeom>
-        </p:spPr>
-        <p:txBody>
-          <a:bodyPr vert="horz" lIns="91440" tIns="45720" rIns="91440" bIns="45720" rtlCol="0" anchor="ctr">
-            <a:normAutofit/>
-          </a:bodyPr>
-          <a:lstStyle>
-            <a:lvl1pPr algn="ctr" defTabSz="914400" rtl="0" eaLnBrk="1" latinLnBrk="0" hangingPunct="1">
-              <a:spcBef>
-                <a:spcPct val="0"/>
-              </a:spcBef>
-              <a:buNone/>
-              <a:defRPr sz="4400" kern="1200">
-                <a:solidFill>
-                  <a:schemeClr val="tx1"/>
-                </a:solidFill>
-                <a:latin typeface="+mj-lt"/>
-                <a:ea typeface="+mj-ea"/>
-                <a:cs typeface="+mj-cs"/>
-              </a:defRPr>
-            </a:lvl1pPr>
-          </a:lstStyle>
-          <a:p>
-            <a:pPr algn="l"/>
-            <a:r>
-              <a:rPr sz="1400" b="1">
-                <a:solidFill>
-                  <a:srgbClr val="013EF5"/>
-                </a:solidFill>
-                <a:latin typeface="DejaVu Sans"/>
-              </a:rPr>
-              <a:t>1.3 &gt; DEDICATED GAS PIPELINE UPDATE &gt; Environmental Performance Indicators</a:t>
-            </a:r>
-          </a:p>
-        </p:txBody>
-      </p:sp>
-      <p:pic>
-        <p:nvPicPr>
-          <p:cNvPr id="11" name="Imagen 10">
-            <a:extLst>
-              <a:ext uri="{FF2B5EF4-FFF2-40B4-BE49-F238E27FC236}">
-                <a16:creationId xmlns:a16="http://schemas.microsoft.com/office/drawing/2014/main" id="{B890EEC0-89A1-F0FA-6F0E-CA480F8EF46C}"/>
-              </a:ext>
-            </a:extLst>
-          </p:cNvPr>
-          <p:cNvPicPr>
-            <a:picLocks noChangeAspect="1"/>
-          </p:cNvPicPr>
-          <p:nvPr/>
-        </p:nvPicPr>
-        <p:blipFill rotWithShape="1">
-          <a:blip r:embed="rId2"/>
-          <a:srcRect t="-1" r="54800" b="49955"/>
-          <a:stretch/>
-        </p:blipFill>
-        <p:spPr>
-          <a:xfrm>
-            <a:off x="8549908" y="117682"/>
-            <a:ext cx="274715" cy="232529"/>
-          </a:xfrm>
-          <a:prstGeom prst="rect">
-            <a:avLst/>
-          </a:prstGeom>
-        </p:spPr>
-      </p:pic>
-      <p:sp>
-        <p:nvSpPr>
-          <p:cNvPr id="12" name="CuadroTexto 11">
-            <a:extLst>
-              <a:ext uri="{FF2B5EF4-FFF2-40B4-BE49-F238E27FC236}">
-                <a16:creationId xmlns:a16="http://schemas.microsoft.com/office/drawing/2014/main" id="{8B51CD8C-DB5F-892A-4B92-E56F0244E354}"/>
-              </a:ext>
-            </a:extLst>
-          </p:cNvPr>
-          <p:cNvSpPr txBox="1"/>
-          <p:nvPr/>
-        </p:nvSpPr>
-        <p:spPr>
-          <a:xfrm>
-            <a:off x="8231453" y="321314"/>
-            <a:ext cx="1151431" cy="215444"/>
-          </a:xfrm>
-          <a:prstGeom prst="rect">
-            <a:avLst/>
-          </a:prstGeom>
-          <a:noFill/>
-        </p:spPr>
-        <p:txBody>
-          <a:bodyPr wrap="square" rtlCol="0">
-            <a:spAutoFit/>
-          </a:bodyPr>
-          <a:lstStyle/>
-          <a:p>
-            <a:r>
-              <a:rPr lang="en-GB" sz="800" spc="100" noProof="0" dirty="0">
-                <a:solidFill>
-                  <a:srgbClr val="FF0000"/>
-                </a:solidFill>
-                <a:latin typeface="Aptos Display" panose="020B0004020202020204" pitchFamily="34" charset="0"/>
-              </a:rPr>
-              <a:t>CONFIDENTIAL</a:t>
-            </a:r>
-          </a:p>
-        </p:txBody>
-      </p:sp>
-      <p:sp>
-        <p:nvSpPr>
-          <p:cNvPr id="13" name="TextBox 12"/>
-          <p:cNvSpPr txBox="1"/>
-          <p:nvPr/>
-        </p:nvSpPr>
-        <p:spPr>
-          <a:xfrm>
-            <a:off x="438912" y="832104"/>
-            <a:ext cx="8321040" cy="237744"/>
-          </a:xfrm>
-          <a:prstGeom prst="rect">
-            <a:avLst/>
-          </a:prstGeom>
-          <a:noFill/>
-        </p:spPr>
-        <p:txBody>
-          <a:bodyPr wrap="square" lIns="18288" rIns="18288" tIns="0" bIns="0">
-            <a:spAutoFit/>
-          </a:bodyPr>
-          <a:lstStyle/>
-          <a:p>
-            <a:pPr>
-              <a:spcAft>
-                <a:spcPts val="500"/>
-              </a:spcAft>
-              <a:defRPr sz="900" b="0">
-                <a:solidFill>
-                  <a:srgbClr val="68717D"/>
-                </a:solidFill>
-                <a:latin typeface="DejaVu Sans"/>
-              </a:defRPr>
-            </a:pPr>
-            <a:r>
-              <a:t>August–September historical data</a:t>
-            </a:r>
-          </a:p>
-        </p:txBody>
-      </p:sp>
-      <p:sp>
-        <p:nvSpPr>
-          <p:cNvPr id="14" name="TextBox 13"/>
-          <p:cNvSpPr txBox="1"/>
-          <p:nvPr/>
-        </p:nvSpPr>
-        <p:spPr>
-          <a:xfrm>
-            <a:off x="484632" y="1207008"/>
-            <a:ext cx="4023360" cy="274320"/>
-          </a:xfrm>
-          <a:prstGeom prst="rect">
-            <a:avLst/>
-          </a:prstGeom>
-          <a:noFill/>
-        </p:spPr>
-        <p:txBody>
-          <a:bodyPr wrap="square" lIns="18288" rIns="18288" tIns="0" bIns="0">
-            <a:spAutoFit/>
-          </a:bodyPr>
-          <a:lstStyle/>
-          <a:p>
-            <a:pPr>
-              <a:spcAft>
-                <a:spcPts val="500"/>
-              </a:spcAft>
-              <a:defRPr sz="1100" b="1">
-                <a:solidFill>
-                  <a:srgbClr val="013EF5"/>
-                </a:solidFill>
-                <a:latin typeface="DejaVu Sans"/>
-              </a:defRPr>
-            </a:pPr>
-            <a:r>
-              <a:t>TOTAL WASTE GENERATION (kg/month)</a:t>
-            </a:r>
-          </a:p>
-        </p:txBody>
-      </p:sp>
-      <p:graphicFrame>
-        <p:nvGraphicFramePr>
-          <p:cNvPr id="15" name="Chart 14"/>
-          <p:cNvGraphicFramePr>
-            <a:graphicFrameLocks noGrp="1"/>
-          </p:cNvGraphicFramePr>
-          <p:nvPr/>
-        </p:nvGraphicFramePr>
-        <p:xfrm>
-          <a:off x="457200" y="1572768"/>
-          <a:ext cx="3063240" cy="2121408"/>
-        </p:xfrm>
-        <a:graphic>
-          <a:graphicData uri="http://schemas.openxmlformats.org/drawingml/2006/chart">
-            <c:chart xmlns:c="http://schemas.openxmlformats.org/drawingml/2006/chart" r:id="rId3"/>
-          </a:graphicData>
-        </a:graphic>
-      </p:graphicFrame>
-      <p:sp>
-        <p:nvSpPr>
-          <p:cNvPr id="16" name="Rectangle 15"/>
-          <p:cNvSpPr/>
-          <p:nvPr/>
-        </p:nvSpPr>
-        <p:spPr>
-          <a:xfrm>
-            <a:off x="4114800" y="1901952"/>
-            <a:ext cx="2240280" cy="1024128"/>
-          </a:xfrm>
-          <a:prstGeom prst="rect">
-            <a:avLst/>
-          </a:prstGeom>
-          <a:solidFill>
-            <a:srgbClr val="F2F3F5"/>
-          </a:solidFill>
-          <a:ln>
-            <a:noFill/>
-          </a:ln>
-          <a:effectLst/>
-        </p:spPr>
-        <p:style>
-          <a:lnRef idx="1">
-            <a:schemeClr val="accent1"/>
-          </a:lnRef>
-          <a:fillRef idx="3">
-            <a:schemeClr val="accent1"/>
-          </a:fillRef>
-          <a:effectRef idx="2">
-            <a:schemeClr val="accent1"/>
-          </a:effectRef>
-          <a:fontRef idx="minor">
-            <a:schemeClr val="lt1"/>
-          </a:fontRef>
-        </p:style>
-        <p:txBody>
-          <a:bodyPr rtlCol="0" anchor="ctr"/>
-          <a:lstStyle/>
-          <a:p>
-            <a:pPr algn="ctr"/>
-          </a:p>
-        </p:txBody>
-      </p:sp>
-      <p:sp>
-        <p:nvSpPr>
-          <p:cNvPr id="17" name="Rectangle 16"/>
-          <p:cNvSpPr/>
-          <p:nvPr/>
-        </p:nvSpPr>
-        <p:spPr>
-          <a:xfrm>
-            <a:off x="4114800" y="1901952"/>
-            <a:ext cx="50292" cy="1024128"/>
-          </a:xfrm>
-          <a:prstGeom prst="rect">
-            <a:avLst/>
-          </a:prstGeom>
-          <a:solidFill>
-            <a:srgbClr val="013EF5"/>
-          </a:solidFill>
-          <a:ln>
-            <a:noFill/>
-          </a:ln>
-          <a:effectLst/>
-        </p:spPr>
-        <p:style>
-          <a:lnRef idx="1">
-            <a:schemeClr val="accent1"/>
-          </a:lnRef>
-          <a:fillRef idx="3">
-            <a:schemeClr val="accent1"/>
-          </a:fillRef>
-          <a:effectRef idx="2">
-            <a:schemeClr val="accent1"/>
-          </a:effectRef>
-          <a:fontRef idx="minor">
-            <a:schemeClr val="lt1"/>
-          </a:fontRef>
-        </p:style>
-        <p:txBody>
-          <a:bodyPr rtlCol="0" anchor="ctr"/>
-          <a:lstStyle/>
-          <a:p>
-            <a:pPr algn="ctr"/>
-          </a:p>
-        </p:txBody>
-      </p:sp>
-      <p:sp>
-        <p:nvSpPr>
-          <p:cNvPr id="18" name="TextBox 17"/>
-          <p:cNvSpPr txBox="1"/>
-          <p:nvPr/>
-        </p:nvSpPr>
-        <p:spPr>
-          <a:xfrm>
-            <a:off x="4224528" y="1984248"/>
-            <a:ext cx="2057400" cy="320040"/>
-          </a:xfrm>
-          <a:prstGeom prst="rect">
-            <a:avLst/>
-          </a:prstGeom>
-          <a:noFill/>
-        </p:spPr>
-        <p:txBody>
-          <a:bodyPr wrap="square" lIns="18288" rIns="18288" tIns="0" bIns="0">
-            <a:spAutoFit/>
-          </a:bodyPr>
-          <a:lstStyle/>
-          <a:p>
-            <a:pPr>
-              <a:spcAft>
-                <a:spcPts val="500"/>
-              </a:spcAft>
-              <a:defRPr sz="850" b="1">
-                <a:solidFill>
-                  <a:srgbClr val="68717D"/>
-                </a:solidFill>
-                <a:latin typeface="DejaVu Sans"/>
-              </a:defRPr>
-            </a:pPr>
-            <a:r>
-              <a:t>% Waste recovery</a:t>
-            </a:r>
-          </a:p>
-        </p:txBody>
-      </p:sp>
-      <p:sp>
-        <p:nvSpPr>
-          <p:cNvPr id="19" name="TextBox 18"/>
-          <p:cNvSpPr txBox="1"/>
-          <p:nvPr/>
-        </p:nvSpPr>
-        <p:spPr>
-          <a:xfrm>
-            <a:off x="4224528" y="2359152"/>
-            <a:ext cx="2011680" cy="475488"/>
-          </a:xfrm>
-          <a:prstGeom prst="rect">
-            <a:avLst/>
-          </a:prstGeom>
-          <a:noFill/>
-        </p:spPr>
-        <p:txBody>
-          <a:bodyPr wrap="square" lIns="18288" rIns="18288" tIns="0" bIns="0">
-            <a:spAutoFit/>
-          </a:bodyPr>
-          <a:lstStyle/>
-          <a:p>
-            <a:pPr>
-              <a:spcAft>
-                <a:spcPts val="500"/>
-              </a:spcAft>
-              <a:defRPr sz="2800" b="1">
-                <a:solidFill>
-                  <a:srgbClr val="013EF5"/>
-                </a:solidFill>
-                <a:latin typeface="DejaVu Sans"/>
-              </a:defRPr>
-            </a:pPr>
-            <a:r>
-              <a:t>0%</a:t>
-            </a:r>
-          </a:p>
-        </p:txBody>
-      </p:sp>
-      <p:sp>
-        <p:nvSpPr>
-          <p:cNvPr id="20" name="Rectangle 19"/>
-          <p:cNvSpPr/>
-          <p:nvPr/>
-        </p:nvSpPr>
-        <p:spPr>
-          <a:xfrm>
-            <a:off x="6446520" y="1901952"/>
-            <a:ext cx="2240280" cy="1024128"/>
-          </a:xfrm>
-          <a:prstGeom prst="rect">
-            <a:avLst/>
-          </a:prstGeom>
-          <a:solidFill>
-            <a:srgbClr val="F2F3F5"/>
-          </a:solidFill>
-          <a:ln>
-            <a:noFill/>
-          </a:ln>
-          <a:effectLst/>
-        </p:spPr>
-        <p:style>
-          <a:lnRef idx="1">
-            <a:schemeClr val="accent1"/>
-          </a:lnRef>
-          <a:fillRef idx="3">
-            <a:schemeClr val="accent1"/>
-          </a:fillRef>
-          <a:effectRef idx="2">
-            <a:schemeClr val="accent1"/>
-          </a:effectRef>
-          <a:fontRef idx="minor">
-            <a:schemeClr val="lt1"/>
-          </a:fontRef>
-        </p:style>
-        <p:txBody>
-          <a:bodyPr rtlCol="0" anchor="ctr"/>
-          <a:lstStyle/>
-          <a:p>
-            <a:pPr algn="ctr"/>
-          </a:p>
-        </p:txBody>
-      </p:sp>
-      <p:sp>
-        <p:nvSpPr>
-          <p:cNvPr id="21" name="Rectangle 20"/>
-          <p:cNvSpPr/>
-          <p:nvPr/>
-        </p:nvSpPr>
-        <p:spPr>
-          <a:xfrm>
-            <a:off x="6446520" y="1901952"/>
-            <a:ext cx="50292" cy="1024128"/>
-          </a:xfrm>
-          <a:prstGeom prst="rect">
-            <a:avLst/>
-          </a:prstGeom>
-          <a:solidFill>
-            <a:srgbClr val="013EF5"/>
-          </a:solidFill>
-          <a:ln>
-            <a:noFill/>
-          </a:ln>
-          <a:effectLst/>
-        </p:spPr>
-        <p:style>
-          <a:lnRef idx="1">
-            <a:schemeClr val="accent1"/>
-          </a:lnRef>
-          <a:fillRef idx="3">
-            <a:schemeClr val="accent1"/>
-          </a:fillRef>
-          <a:effectRef idx="2">
-            <a:schemeClr val="accent1"/>
-          </a:effectRef>
-          <a:fontRef idx="minor">
-            <a:schemeClr val="lt1"/>
-          </a:fontRef>
-        </p:style>
-        <p:txBody>
-          <a:bodyPr rtlCol="0" anchor="ctr"/>
-          <a:lstStyle/>
-          <a:p>
-            <a:pPr algn="ctr"/>
-          </a:p>
-        </p:txBody>
-      </p:sp>
-      <p:sp>
-        <p:nvSpPr>
-          <p:cNvPr id="22" name="TextBox 21"/>
-          <p:cNvSpPr txBox="1"/>
-          <p:nvPr/>
-        </p:nvSpPr>
-        <p:spPr>
-          <a:xfrm>
-            <a:off x="6556248" y="1984248"/>
-            <a:ext cx="2057400" cy="320040"/>
-          </a:xfrm>
-          <a:prstGeom prst="rect">
-            <a:avLst/>
-          </a:prstGeom>
-          <a:noFill/>
-        </p:spPr>
-        <p:txBody>
-          <a:bodyPr wrap="square" lIns="18288" rIns="18288" tIns="0" bIns="0">
-            <a:spAutoFit/>
-          </a:bodyPr>
-          <a:lstStyle/>
-          <a:p>
-            <a:pPr>
-              <a:spcAft>
-                <a:spcPts val="500"/>
-              </a:spcAft>
-              <a:defRPr sz="850" b="1">
-                <a:solidFill>
-                  <a:srgbClr val="68717D"/>
-                </a:solidFill>
-                <a:latin typeface="DejaVu Sans"/>
-              </a:defRPr>
-            </a:pPr>
-            <a:r>
-              <a:t>% Waste final disposal / incinerated</a:t>
-            </a:r>
-          </a:p>
-        </p:txBody>
-      </p:sp>
-      <p:sp>
-        <p:nvSpPr>
-          <p:cNvPr id="23" name="TextBox 22"/>
-          <p:cNvSpPr txBox="1"/>
-          <p:nvPr/>
-        </p:nvSpPr>
-        <p:spPr>
-          <a:xfrm>
-            <a:off x="6556248" y="2359152"/>
-            <a:ext cx="2011680" cy="475488"/>
-          </a:xfrm>
-          <a:prstGeom prst="rect">
-            <a:avLst/>
-          </a:prstGeom>
-          <a:noFill/>
-        </p:spPr>
-        <p:txBody>
-          <a:bodyPr wrap="square" lIns="18288" rIns="18288" tIns="0" bIns="0">
-            <a:spAutoFit/>
-          </a:bodyPr>
-          <a:lstStyle/>
-          <a:p>
-            <a:pPr>
-              <a:spcAft>
-                <a:spcPts val="500"/>
-              </a:spcAft>
-              <a:defRPr sz="2800" b="1">
-                <a:solidFill>
-                  <a:srgbClr val="013EF5"/>
-                </a:solidFill>
-                <a:latin typeface="DejaVu Sans"/>
-              </a:defRPr>
-            </a:pPr>
-            <a:r>
-              <a:t>100%</a:t>
-            </a:r>
-          </a:p>
-        </p:txBody>
-      </p:sp>
-      <p:sp>
-        <p:nvSpPr>
-          <p:cNvPr id="24" name="TextBox 23"/>
-          <p:cNvSpPr txBox="1"/>
-          <p:nvPr/>
-        </p:nvSpPr>
-        <p:spPr>
-          <a:xfrm>
-            <a:off x="484632" y="4023360"/>
-            <a:ext cx="4846320" cy="274320"/>
-          </a:xfrm>
-          <a:prstGeom prst="rect">
-            <a:avLst/>
-          </a:prstGeom>
-          <a:noFill/>
-        </p:spPr>
-        <p:txBody>
-          <a:bodyPr wrap="square" lIns="18288" rIns="18288" tIns="0" bIns="0">
-            <a:spAutoFit/>
-          </a:bodyPr>
-          <a:lstStyle/>
-          <a:p>
-            <a:pPr>
-              <a:spcAft>
-                <a:spcPts val="500"/>
-              </a:spcAft>
-              <a:defRPr sz="1100" b="1">
-                <a:solidFill>
-                  <a:srgbClr val="013EF5"/>
-                </a:solidFill>
-                <a:latin typeface="DejaVu Sans"/>
-              </a:defRPr>
-            </a:pPr>
-            <a:r>
-              <a:t>FRESHWATER CONSUMPTION (m³/month)</a:t>
-            </a:r>
-          </a:p>
-        </p:txBody>
-      </p:sp>
-      <p:graphicFrame>
-        <p:nvGraphicFramePr>
-          <p:cNvPr id="25" name="Chart 24"/>
-          <p:cNvGraphicFramePr>
-            <a:graphicFrameLocks noGrp="1"/>
-          </p:cNvGraphicFramePr>
-          <p:nvPr/>
-        </p:nvGraphicFramePr>
-        <p:xfrm>
-          <a:off x="457200" y="4370832"/>
-          <a:ext cx="3063240" cy="1947672"/>
-        </p:xfrm>
-        <a:graphic>
-          <a:graphicData uri="http://schemas.openxmlformats.org/drawingml/2006/chart">
-            <c:chart xmlns:c="http://schemas.openxmlformats.org/drawingml/2006/chart" r:id="rId4"/>
-          </a:graphicData>
-        </a:graphic>
-      </p:graphicFrame>
-      <p:sp>
-        <p:nvSpPr>
-          <p:cNvPr id="26" name="TextBox 25"/>
-          <p:cNvSpPr txBox="1"/>
-          <p:nvPr/>
-        </p:nvSpPr>
-        <p:spPr>
-          <a:xfrm>
-            <a:off x="3474720" y="6601968"/>
-            <a:ext cx="4389120" cy="155448"/>
-          </a:xfrm>
-          <a:prstGeom prst="rect">
-            <a:avLst/>
-          </a:prstGeom>
-          <a:noFill/>
-        </p:spPr>
-        <p:txBody>
-          <a:bodyPr wrap="square" lIns="18288" rIns="18288" tIns="0" bIns="0">
-            <a:spAutoFit/>
-          </a:bodyPr>
-          <a:lstStyle/>
-          <a:p>
-            <a:pPr>
-              <a:spcAft>
-                <a:spcPts val="500"/>
-              </a:spcAft>
-              <a:defRPr sz="650" b="0">
-                <a:solidFill>
-                  <a:srgbClr val="68717D"/>
-                </a:solidFill>
-                <a:latin typeface="DejaVu Sans"/>
-              </a:defRPr>
-            </a:pPr>
-            <a:r>
-              <a:t>WORKING DRAFT · October topics pending</a:t>
-            </a:r>
-          </a:p>
-        </p:txBody>
-      </p:sp>
-      <p:sp>
-        <p:nvSpPr>
-          <p:cNvPr id="27" name="TextBox 26"/>
-          <p:cNvSpPr txBox="1"/>
-          <p:nvPr/>
-        </p:nvSpPr>
-        <p:spPr>
-          <a:xfrm>
-            <a:off x="8595360" y="6556248"/>
-            <a:ext cx="274320" cy="201168"/>
-          </a:xfrm>
-          <a:prstGeom prst="rect">
-            <a:avLst/>
-          </a:prstGeom>
-          <a:noFill/>
-        </p:spPr>
-        <p:txBody>
-          <a:bodyPr wrap="square" lIns="18288" rIns="18288" tIns="0" bIns="0">
-            <a:spAutoFit/>
-          </a:bodyPr>
-          <a:lstStyle/>
-          <a:p>
-            <a:pPr algn="r">
-              <a:spcAft>
-                <a:spcPts val="500"/>
-              </a:spcAft>
-              <a:defRPr sz="800" b="0">
-                <a:solidFill>
-                  <a:srgbClr val="68717D"/>
-                </a:solidFill>
-                <a:latin typeface="DejaVu Sans"/>
-              </a:defRPr>
-            </a:pPr>
-            <a:r>
-              <a:t>6</a:t>
-            </a:r>
-          </a:p>
-        </p:txBody>
-      </p:sp>
-    </p:spTree>
-  </p:cSld>
-  <p:clrMapOvr>
-    <a:masterClrMapping/>
-  </p:clrMapOvr>
-</p:sld>
-</file>
-
-<file path=ppt/slides/slide9.xml><?xml version="1.0" encoding="utf-8"?>
-<p:sld xmlns:a="http://schemas.openxmlformats.org/drawingml/2006/main" xmlns:p="http://schemas.openxmlformats.org/presentationml/2006/main" xmlns:r="http://schemas.openxmlformats.org/officeDocument/2006/relationships">
-  <p:cSld>
-    <p:spTree>
-      <p:nvGrpSpPr>
-        <p:cNvPr id="1" name=""/>
-        <p:cNvGrpSpPr/>
-        <p:nvPr/>
-      </p:nvGrpSpPr>
-      <p:grpSpPr/>
-      <p:sp>
-        <p:nvSpPr>
-          <p:cNvPr id="8" name="Rectángulo 7">
-            <a:extLst>
-              <a:ext uri="{FF2B5EF4-FFF2-40B4-BE49-F238E27FC236}">
-                <a16:creationId xmlns:a16="http://schemas.microsoft.com/office/drawing/2014/main" id="{E0F0ACF1-FB3B-891E-E4C9-CEDACE965B70}"/>
-              </a:ext>
-            </a:extLst>
-          </p:cNvPr>
-          <p:cNvSpPr/>
-          <p:nvPr/>
-        </p:nvSpPr>
-        <p:spPr>
-          <a:xfrm>
-            <a:off x="0" y="0"/>
-            <a:ext cx="9144000" cy="706582"/>
-          </a:xfrm>
-          <a:prstGeom prst="rect">
-            <a:avLst/>
-          </a:prstGeom>
-          <a:solidFill>
-            <a:schemeClr val="bg1">
-              <a:lumMod val="95000"/>
-            </a:schemeClr>
-          </a:solidFill>
-          <a:ln>
-            <a:noFill/>
-          </a:ln>
-        </p:spPr>
-        <p:style>
-          <a:lnRef idx="2">
-            <a:schemeClr val="accent1">
-              <a:shade val="50000"/>
-            </a:schemeClr>
-          </a:lnRef>
-          <a:fillRef idx="1">
-            <a:schemeClr val="accent1"/>
-          </a:fillRef>
-          <a:effectRef idx="0">
-            <a:schemeClr val="accent1"/>
-          </a:effectRef>
-          <a:fontRef idx="minor">
-            <a:schemeClr val="lt1"/>
-          </a:fontRef>
-        </p:style>
-        <p:txBody>
-          <a:bodyPr rtlCol="0" anchor="ctr"/>
-          <a:lstStyle/>
-          <a:p>
-            <a:pPr algn="ctr"/>
-            <a:endParaRPr lang="en-GB" noProof="0" dirty="0"/>
-          </a:p>
-        </p:txBody>
-      </p:sp>
-      <p:sp>
-        <p:nvSpPr>
-          <p:cNvPr id="9" name="Título 1">
-            <a:extLst>
-              <a:ext uri="{FF2B5EF4-FFF2-40B4-BE49-F238E27FC236}">
-                <a16:creationId xmlns:a16="http://schemas.microsoft.com/office/drawing/2014/main" id="{2C399A2C-904E-A0D7-BF10-0536804170B1}"/>
-              </a:ext>
-            </a:extLst>
-          </p:cNvPr>
-          <p:cNvSpPr txBox="1">
-            <a:spLocks/>
-          </p:cNvSpPr>
-          <p:nvPr/>
-        </p:nvSpPr>
-        <p:spPr>
-          <a:xfrm>
-            <a:off x="179509" y="142504"/>
-            <a:ext cx="7863840" cy="475488"/>
-          </a:xfrm>
-          <a:prstGeom prst="rect">
-            <a:avLst/>
-          </a:prstGeom>
-        </p:spPr>
-        <p:txBody>
-          <a:bodyPr vert="horz" lIns="91440" tIns="45720" rIns="91440" bIns="45720" rtlCol="0" anchor="ctr">
-            <a:normAutofit/>
-          </a:bodyPr>
-          <a:lstStyle>
-            <a:lvl1pPr algn="ctr" defTabSz="914400" rtl="0" eaLnBrk="1" latinLnBrk="0" hangingPunct="1">
-              <a:spcBef>
-                <a:spcPct val="0"/>
-              </a:spcBef>
-              <a:buNone/>
-              <a:defRPr sz="4400" kern="1200">
-                <a:solidFill>
-                  <a:schemeClr val="tx1"/>
-                </a:solidFill>
-                <a:latin typeface="+mj-lt"/>
-                <a:ea typeface="+mj-ea"/>
-                <a:cs typeface="+mj-cs"/>
-              </a:defRPr>
-            </a:lvl1pPr>
-          </a:lstStyle>
-          <a:p>
-            <a:pPr algn="l"/>
-            <a:r>
-              <a:rPr sz="1400" b="1">
-                <a:solidFill>
-                  <a:srgbClr val="013EF5"/>
-                </a:solidFill>
-                <a:latin typeface="DejaVu Sans"/>
-              </a:rPr>
-              <a:t>1.3 &gt; DEDICATED GAS PIPELINE UPDATE &gt; Environment | October Highlights</a:t>
-            </a:r>
-          </a:p>
-        </p:txBody>
-      </p:sp>
-      <p:pic>
-        <p:nvPicPr>
-          <p:cNvPr id="11" name="Imagen 10">
-            <a:extLst>
-              <a:ext uri="{FF2B5EF4-FFF2-40B4-BE49-F238E27FC236}">
-                <a16:creationId xmlns:a16="http://schemas.microsoft.com/office/drawing/2014/main" id="{B890EEC0-89A1-F0FA-6F0E-CA480F8EF46C}"/>
-              </a:ext>
-            </a:extLst>
-          </p:cNvPr>
-          <p:cNvPicPr>
-            <a:picLocks noChangeAspect="1"/>
-          </p:cNvPicPr>
-          <p:nvPr/>
-        </p:nvPicPr>
-        <p:blipFill rotWithShape="1">
-          <a:blip r:embed="rId2"/>
-          <a:srcRect t="-1" r="54800" b="49955"/>
-          <a:stretch/>
-        </p:blipFill>
-        <p:spPr>
-          <a:xfrm>
-            <a:off x="8549908" y="117682"/>
-            <a:ext cx="274715" cy="232529"/>
-          </a:xfrm>
-          <a:prstGeom prst="rect">
-            <a:avLst/>
-          </a:prstGeom>
-        </p:spPr>
-      </p:pic>
-      <p:sp>
-        <p:nvSpPr>
-          <p:cNvPr id="12" name="CuadroTexto 11">
-            <a:extLst>
-              <a:ext uri="{FF2B5EF4-FFF2-40B4-BE49-F238E27FC236}">
-                <a16:creationId xmlns:a16="http://schemas.microsoft.com/office/drawing/2014/main" id="{8B51CD8C-DB5F-892A-4B92-E56F0244E354}"/>
-              </a:ext>
-            </a:extLst>
-          </p:cNvPr>
-          <p:cNvSpPr txBox="1"/>
-          <p:nvPr/>
-        </p:nvSpPr>
-        <p:spPr>
-          <a:xfrm>
-            <a:off x="8231453" y="321314"/>
-            <a:ext cx="1151431" cy="215444"/>
-          </a:xfrm>
-          <a:prstGeom prst="rect">
-            <a:avLst/>
-          </a:prstGeom>
-          <a:noFill/>
-        </p:spPr>
-        <p:txBody>
-          <a:bodyPr wrap="square" rtlCol="0">
-            <a:spAutoFit/>
-          </a:bodyPr>
-          <a:lstStyle/>
-          <a:p>
-            <a:r>
-              <a:rPr lang="en-GB" sz="800" spc="100" noProof="0" dirty="0">
-                <a:solidFill>
-                  <a:srgbClr val="FF0000"/>
-                </a:solidFill>
-                <a:latin typeface="Aptos Display" panose="020B0004020202020204" pitchFamily="34" charset="0"/>
-              </a:rPr>
-              <a:t>CONFIDENTIAL</a:t>
-            </a:r>
-          </a:p>
-        </p:txBody>
-      </p:sp>
-      <p:sp>
-        <p:nvSpPr>
-          <p:cNvPr id="13" name="TextBox 12"/>
-          <p:cNvSpPr txBox="1"/>
-          <p:nvPr/>
-        </p:nvSpPr>
-        <p:spPr>
-          <a:xfrm>
-            <a:off x="411480" y="850392"/>
-            <a:ext cx="8321040" cy="320040"/>
-          </a:xfrm>
-          <a:prstGeom prst="rect">
-            <a:avLst/>
-          </a:prstGeom>
-          <a:noFill/>
-        </p:spPr>
-        <p:txBody>
-          <a:bodyPr wrap="square" lIns="18288" rIns="18288" tIns="0" bIns="0">
-            <a:spAutoFit/>
-          </a:bodyPr>
-          <a:lstStyle/>
-          <a:p>
-            <a:pPr>
-              <a:spcAft>
-                <a:spcPts val="500"/>
-              </a:spcAft>
-              <a:defRPr sz="1100" b="1">
-                <a:solidFill>
-                  <a:srgbClr val="013EF5"/>
-                </a:solidFill>
-                <a:latin typeface="DejaVu Sans"/>
-              </a:defRPr>
-            </a:pPr>
-            <a:r>
-              <a:t>OCTOBER 2026 · PHOTOS &amp; RELEVANT HIGHLIGHTS · cut-off 27 Oct</a:t>
-            </a:r>
-          </a:p>
-        </p:txBody>
-      </p:sp>
-      <p:sp>
-        <p:nvSpPr>
-          <p:cNvPr id="14" name="Rectangle 13"/>
-          <p:cNvSpPr/>
-          <p:nvPr/>
-        </p:nvSpPr>
-        <p:spPr>
-          <a:xfrm>
-            <a:off x="411480" y="1417320"/>
-            <a:ext cx="4023360" cy="2331720"/>
-          </a:xfrm>
-          <a:prstGeom prst="rect">
-            <a:avLst/>
-          </a:prstGeom>
-          <a:solidFill>
-            <a:srgbClr val="F2F3F5"/>
-          </a:solidFill>
-          <a:ln>
-            <a:solidFill>
-              <a:srgbClr val="CDD2D9"/>
-            </a:solidFill>
-          </a:ln>
-          <a:effectLst/>
-        </p:spPr>
-        <p:style>
-          <a:lnRef idx="1">
-            <a:schemeClr val="accent1"/>
-          </a:lnRef>
-          <a:fillRef idx="3">
-            <a:schemeClr val="accent1"/>
-          </a:fillRef>
-          <a:effectRef idx="2">
-            <a:schemeClr val="accent1"/>
-          </a:effectRef>
-          <a:fontRef idx="minor">
-            <a:schemeClr val="lt1"/>
-          </a:fontRef>
-        </p:style>
-        <p:txBody>
-          <a:bodyPr rtlCol="0" anchor="ctr"/>
-          <a:lstStyle/>
-          <a:p>
-            <a:pPr algn="ctr"/>
-          </a:p>
-        </p:txBody>
-      </p:sp>
-      <p:sp>
-        <p:nvSpPr>
-          <p:cNvPr id="15" name="TextBox 14"/>
-          <p:cNvSpPr txBox="1"/>
-          <p:nvPr/>
-        </p:nvSpPr>
-        <p:spPr>
-          <a:xfrm>
-            <a:off x="548640" y="2148840"/>
-            <a:ext cx="3749039" cy="640080"/>
-          </a:xfrm>
-          <a:prstGeom prst="rect">
-            <a:avLst/>
-          </a:prstGeom>
-          <a:noFill/>
-        </p:spPr>
-        <p:txBody>
-          <a:bodyPr wrap="square" lIns="18288" rIns="18288" tIns="0" bIns="0">
-            <a:spAutoFit/>
-          </a:bodyPr>
-          <a:lstStyle/>
-          <a:p>
-            <a:pPr algn="ctr">
-              <a:spcAft>
-                <a:spcPts val="500"/>
-              </a:spcAft>
-              <a:defRPr sz="1500" b="0">
-                <a:solidFill>
-                  <a:srgbClr val="68717D"/>
-                </a:solidFill>
-                <a:latin typeface="DejaVu Sans"/>
-              </a:defRPr>
-            </a:pPr>
-            <a:r>
-              <a:t>OCTOBER PHOTO 1</a:t>
-            </a:r>
-          </a:p>
-          <a:p>
-            <a:pPr algn="ctr">
-              <a:spcAft>
-                <a:spcPts val="500"/>
-              </a:spcAft>
-              <a:defRPr sz="1500" b="0">
-                <a:solidFill>
-                  <a:srgbClr val="68717D"/>
-                </a:solidFill>
-                <a:latin typeface="DejaVu Sans"/>
-              </a:defRPr>
-            </a:pPr>
-            <a:r>
-              <a:t>Pending actual photo</a:t>
-            </a:r>
-          </a:p>
-        </p:txBody>
-      </p:sp>
-      <p:sp>
-        <p:nvSpPr>
-          <p:cNvPr id="16" name="TextBox 15"/>
-          <p:cNvSpPr txBox="1"/>
-          <p:nvPr/>
-        </p:nvSpPr>
-        <p:spPr>
-          <a:xfrm>
-            <a:off x="411480" y="3867912"/>
-            <a:ext cx="4023360" cy="502920"/>
-          </a:xfrm>
-          <a:prstGeom prst="rect">
-            <a:avLst/>
-          </a:prstGeom>
-          <a:noFill/>
-        </p:spPr>
-        <p:txBody>
-          <a:bodyPr wrap="square" lIns="18288" rIns="18288" tIns="0" bIns="0">
-            <a:spAutoFit/>
-          </a:bodyPr>
-          <a:lstStyle/>
-          <a:p>
-            <a:pPr>
-              <a:spcAft>
-                <a:spcPts val="500"/>
-              </a:spcAft>
-              <a:defRPr sz="950" b="0">
-                <a:solidFill>
-                  <a:srgbClr val="68717D"/>
-                </a:solidFill>
-                <a:latin typeface="DejaVu Sans"/>
-              </a:defRPr>
-            </a:pPr>
-            <a:r>
-              <a:t>Date / location / activity: pending confirmation</a:t>
-            </a:r>
-          </a:p>
-        </p:txBody>
-      </p:sp>
-      <p:sp>
-        <p:nvSpPr>
-          <p:cNvPr id="17" name="Rectangle 16"/>
-          <p:cNvSpPr/>
-          <p:nvPr/>
-        </p:nvSpPr>
-        <p:spPr>
-          <a:xfrm>
-            <a:off x="4681728" y="1417320"/>
-            <a:ext cx="4023360" cy="2331720"/>
-          </a:xfrm>
-          <a:prstGeom prst="rect">
-            <a:avLst/>
-          </a:prstGeom>
-          <a:solidFill>
-            <a:srgbClr val="F2F3F5"/>
-          </a:solidFill>
-          <a:ln>
-            <a:solidFill>
-              <a:srgbClr val="CDD2D9"/>
-            </a:solidFill>
-          </a:ln>
-          <a:effectLst/>
-        </p:spPr>
-        <p:style>
-          <a:lnRef idx="1">
-            <a:schemeClr val="accent1"/>
-          </a:lnRef>
-          <a:fillRef idx="3">
-            <a:schemeClr val="accent1"/>
-          </a:fillRef>
-          <a:effectRef idx="2">
-            <a:schemeClr val="accent1"/>
-          </a:effectRef>
-          <a:fontRef idx="minor">
-            <a:schemeClr val="lt1"/>
-          </a:fontRef>
-        </p:style>
-        <p:txBody>
-          <a:bodyPr rtlCol="0" anchor="ctr"/>
-          <a:lstStyle/>
-          <a:p>
-            <a:pPr algn="ctr"/>
-          </a:p>
-        </p:txBody>
-      </p:sp>
-      <p:sp>
-        <p:nvSpPr>
-          <p:cNvPr id="18" name="TextBox 17"/>
-          <p:cNvSpPr txBox="1"/>
-          <p:nvPr/>
-        </p:nvSpPr>
-        <p:spPr>
-          <a:xfrm>
-            <a:off x="4818888" y="2148840"/>
-            <a:ext cx="3749039" cy="640080"/>
-          </a:xfrm>
-          <a:prstGeom prst="rect">
-            <a:avLst/>
-          </a:prstGeom>
-          <a:noFill/>
-        </p:spPr>
-        <p:txBody>
-          <a:bodyPr wrap="square" lIns="18288" rIns="18288" tIns="0" bIns="0">
-            <a:spAutoFit/>
-          </a:bodyPr>
-          <a:lstStyle/>
-          <a:p>
-            <a:pPr algn="ctr">
-              <a:spcAft>
-                <a:spcPts val="500"/>
-              </a:spcAft>
-              <a:defRPr sz="1500" b="0">
-                <a:solidFill>
-                  <a:srgbClr val="68717D"/>
-                </a:solidFill>
-                <a:latin typeface="DejaVu Sans"/>
-              </a:defRPr>
-            </a:pPr>
-            <a:r>
-              <a:t>OCTOBER PHOTO 2</a:t>
-            </a:r>
-          </a:p>
-          <a:p>
-            <a:pPr algn="ctr">
-              <a:spcAft>
-                <a:spcPts val="500"/>
-              </a:spcAft>
-              <a:defRPr sz="1500" b="0">
-                <a:solidFill>
-                  <a:srgbClr val="68717D"/>
-                </a:solidFill>
-                <a:latin typeface="DejaVu Sans"/>
-              </a:defRPr>
-            </a:pPr>
-            <a:r>
-              <a:t>Pending actual photo</a:t>
-            </a:r>
-          </a:p>
-        </p:txBody>
-      </p:sp>
-      <p:sp>
-        <p:nvSpPr>
-          <p:cNvPr id="19" name="TextBox 18"/>
-          <p:cNvSpPr txBox="1"/>
-          <p:nvPr/>
-        </p:nvSpPr>
-        <p:spPr>
-          <a:xfrm>
-            <a:off x="4681728" y="3867912"/>
-            <a:ext cx="4023360" cy="502920"/>
-          </a:xfrm>
-          <a:prstGeom prst="rect">
-            <a:avLst/>
-          </a:prstGeom>
-          <a:noFill/>
-        </p:spPr>
-        <p:txBody>
-          <a:bodyPr wrap="square" lIns="18288" rIns="18288" tIns="0" bIns="0">
-            <a:spAutoFit/>
-          </a:bodyPr>
-          <a:lstStyle/>
-          <a:p>
-            <a:pPr>
-              <a:spcAft>
-                <a:spcPts val="500"/>
-              </a:spcAft>
-              <a:defRPr sz="950" b="0">
-                <a:solidFill>
-                  <a:srgbClr val="68717D"/>
-                </a:solidFill>
-                <a:latin typeface="DejaVu Sans"/>
-              </a:defRPr>
-            </a:pPr>
-            <a:r>
-              <a:t>Date / location / activity: pending confirmation</a:t>
-            </a:r>
-          </a:p>
-        </p:txBody>
-      </p:sp>
-      <p:sp>
-        <p:nvSpPr>
-          <p:cNvPr id="20" name="Rectangle 19"/>
-          <p:cNvSpPr/>
-          <p:nvPr/>
-        </p:nvSpPr>
-        <p:spPr>
-          <a:xfrm>
-            <a:off x="411480" y="4590288"/>
-            <a:ext cx="8293608" cy="1554480"/>
-          </a:xfrm>
-          <a:prstGeom prst="rect">
-            <a:avLst/>
-          </a:prstGeom>
-          <a:solidFill>
-            <a:srgbClr val="F2F3F5"/>
-          </a:solidFill>
-          <a:ln>
-            <a:noFill/>
-          </a:ln>
-          <a:effectLst/>
-        </p:spPr>
-        <p:style>
-          <a:lnRef idx="1">
-            <a:schemeClr val="accent1"/>
-          </a:lnRef>
-          <a:fillRef idx="3">
-            <a:schemeClr val="accent1"/>
-          </a:fillRef>
-          <a:effectRef idx="2">
-            <a:schemeClr val="accent1"/>
-          </a:effectRef>
-          <a:fontRef idx="minor">
-            <a:schemeClr val="lt1"/>
-          </a:fontRef>
-        </p:style>
-        <p:txBody>
-          <a:bodyPr rtlCol="0" anchor="ctr"/>
-          <a:lstStyle/>
-          <a:p>
-            <a:pPr algn="ctr"/>
-          </a:p>
-        </p:txBody>
-      </p:sp>
-      <p:sp>
-        <p:nvSpPr>
-          <p:cNvPr id="21" name="TextBox 20"/>
-          <p:cNvSpPr txBox="1"/>
-          <p:nvPr/>
-        </p:nvSpPr>
-        <p:spPr>
-          <a:xfrm>
-            <a:off x="566928" y="4727448"/>
-            <a:ext cx="8001000" cy="274320"/>
-          </a:xfrm>
-          <a:prstGeom prst="rect">
-            <a:avLst/>
-          </a:prstGeom>
-          <a:noFill/>
-        </p:spPr>
-        <p:txBody>
-          <a:bodyPr wrap="square" lIns="18288" rIns="18288" tIns="0" bIns="0">
-            <a:spAutoFit/>
-          </a:bodyPr>
-          <a:lstStyle/>
-          <a:p>
-            <a:pPr>
-              <a:spcAft>
-                <a:spcPts val="500"/>
-              </a:spcAft>
-              <a:defRPr sz="1200" b="1">
-                <a:solidFill>
-                  <a:srgbClr val="013EF5"/>
-                </a:solidFill>
-                <a:latin typeface="DejaVu Sans"/>
-              </a:defRPr>
-            </a:pPr>
-            <a:r>
-              <a:t>ENVIRONMENT — RELEVANT OCTOBER TOPICS</a:t>
-            </a:r>
-          </a:p>
-        </p:txBody>
-      </p:sp>
-      <p:sp>
-        <p:nvSpPr>
-          <p:cNvPr id="22" name="TextBox 21"/>
-          <p:cNvSpPr txBox="1"/>
-          <p:nvPr/>
-        </p:nvSpPr>
-        <p:spPr>
-          <a:xfrm>
-            <a:off x="566928" y="5184648"/>
-            <a:ext cx="7863840" cy="749808"/>
-          </a:xfrm>
-          <a:prstGeom prst="rect">
-            <a:avLst/>
-          </a:prstGeom>
-          <a:noFill/>
-        </p:spPr>
-        <p:txBody>
-          <a:bodyPr wrap="square" lIns="18288" rIns="18288" tIns="0" bIns="0">
-            <a:spAutoFit/>
-          </a:bodyPr>
-          <a:lstStyle/>
-          <a:p>
-            <a:pPr>
-              <a:spcAft>
-                <a:spcPts val="500"/>
-              </a:spcAft>
-              <a:defRPr sz="1200" b="0">
-                <a:solidFill>
-                  <a:srgbClr val="27364A"/>
-                </a:solidFill>
-                <a:latin typeface="DejaVu Sans"/>
-              </a:defRPr>
-            </a:pPr>
-            <a:r>
-              <a:t>[Pending topics from Leandro Doglio]</a:t>
-            </a:r>
-          </a:p>
-          <a:p>
-            <a:pPr>
-              <a:spcAft>
-                <a:spcPts val="500"/>
-              </a:spcAft>
-              <a:defRPr sz="1200" b="0">
-                <a:solidFill>
-                  <a:srgbClr val="27364A"/>
-                </a:solidFill>
-                <a:latin typeface="DejaVu Sans"/>
-              </a:defRPr>
-            </a:pPr>
-            <a:r>
-              <a:t>Confirmed development · relevance · next step</a:t>
-            </a:r>
-          </a:p>
-        </p:txBody>
-      </p:sp>
-      <p:sp>
-        <p:nvSpPr>
-          <p:cNvPr id="23" name="TextBox 22"/>
-          <p:cNvSpPr txBox="1"/>
-          <p:nvPr/>
-        </p:nvSpPr>
-        <p:spPr>
-          <a:xfrm>
-            <a:off x="3474720" y="6601968"/>
-            <a:ext cx="4389120" cy="155448"/>
-          </a:xfrm>
-          <a:prstGeom prst="rect">
-            <a:avLst/>
-          </a:prstGeom>
-          <a:noFill/>
-        </p:spPr>
-        <p:txBody>
-          <a:bodyPr wrap="square" lIns="18288" rIns="18288" tIns="0" bIns="0">
-            <a:spAutoFit/>
-          </a:bodyPr>
-          <a:lstStyle/>
-          <a:p>
-            <a:pPr>
-              <a:spcAft>
-                <a:spcPts val="500"/>
-              </a:spcAft>
-              <a:defRPr sz="650" b="0">
-                <a:solidFill>
-                  <a:srgbClr val="68717D"/>
-                </a:solidFill>
-                <a:latin typeface="DejaVu Sans"/>
-              </a:defRPr>
-            </a:pPr>
-            <a:r>
-              <a:t>WORKING DRAFT · October topics pending</a:t>
-            </a:r>
-          </a:p>
-        </p:txBody>
-      </p:sp>
-      <p:sp>
-        <p:nvSpPr>
-          <p:cNvPr id="24" name="TextBox 23"/>
-          <p:cNvSpPr txBox="1"/>
-          <p:nvPr/>
-        </p:nvSpPr>
-        <p:spPr>
-          <a:xfrm>
-            <a:off x="8595360" y="6556248"/>
-            <a:ext cx="274320" cy="201168"/>
-          </a:xfrm>
-          <a:prstGeom prst="rect">
-            <a:avLst/>
-          </a:prstGeom>
-          <a:noFill/>
-        </p:spPr>
-        <p:txBody>
-          <a:bodyPr wrap="square" lIns="18288" rIns="18288" tIns="0" bIns="0">
-            <a:spAutoFit/>
-          </a:bodyPr>
-          <a:lstStyle/>
-          <a:p>
-            <a:pPr algn="r">
-              <a:spcAft>
-                <a:spcPts val="500"/>
-              </a:spcAft>
-              <a:defRPr sz="800" b="0">
-                <a:solidFill>
-                  <a:srgbClr val="68717D"/>
-                </a:solidFill>
-                <a:latin typeface="DejaVu Sans"/>
-              </a:defRPr>
-            </a:pPr>
-            <a:r>
-              <a:t>7</a:t>
-            </a:r>
-          </a:p>
-        </p:txBody>
-      </p:sp>
-    </p:spTree>
   </p:cSld>
   <p:clrMapOvr>
     <a:masterClrMapping/>

</xml_diff>